<commit_message>
Embed exact UI screenshot graphics into PowerPoint deck and DEMO_PRESENTATION.md
</commit_message>
<xml_diff>
--- a/Smart_Retail_Platform_Demo_Presentation.pptx
+++ b/Smart_Retail_Platform_Demo_Presentation.pptx
@@ -10,9 +10,6 @@
     <p:sldId id="258" r:id="rId9"/>
     <p:sldId id="259" r:id="rId10"/>
     <p:sldId id="260" r:id="rId11"/>
-    <p:sldId id="261" r:id="rId12"/>
-    <p:sldId id="262" r:id="rId13"/>
-    <p:sldId id="263" r:id="rId14"/>
   </p:sldIdLst>
   <p:sldSz cx="12191695" cy="6858000" type="screen4x3"/>
   <p:notesSz cx="6858000" cy="9144000"/>
@@ -3105,57 +3102,14 @@
       <p:grpSpPr/>
       <p:sp>
         <p:nvSpPr>
-          <p:cNvPr id="2" name="Rectangle 1"/>
-          <p:cNvSpPr/>
+          <p:cNvPr id="2" name="TextBox 1"/>
+          <p:cNvSpPr txBox="1"/>
           <p:nvPr/>
         </p:nvSpPr>
         <p:spPr>
           <a:xfrm>
-            <a:off x="731520" y="1645920"/>
-            <a:ext cx="137160" cy="3474720"/>
-          </a:xfrm>
-          <a:prstGeom prst="rect">
-            <a:avLst/>
-          </a:prstGeom>
-          <a:solidFill>
-            <a:srgbClr val="38BDF8"/>
-          </a:solidFill>
-          <a:ln>
-            <a:noFill/>
-          </a:ln>
-        </p:spPr>
-        <p:style>
-          <a:lnRef idx="1">
-            <a:schemeClr val="accent1"/>
-          </a:lnRef>
-          <a:fillRef idx="3">
-            <a:schemeClr val="accent1"/>
-          </a:fillRef>
-          <a:effectRef idx="2">
-            <a:schemeClr val="accent1"/>
-          </a:effectRef>
-          <a:fontRef idx="minor">
-            <a:schemeClr val="lt1"/>
-          </a:fontRef>
-        </p:style>
-        <p:txBody>
-          <a:bodyPr rtlCol="0" anchor="ctr"/>
-          <a:lstStyle/>
-          <a:p>
-            <a:pPr algn="ctr"/>
-          </a:p>
-        </p:txBody>
-      </p:sp>
-      <p:sp>
-        <p:nvSpPr>
-          <p:cNvPr id="3" name="TextBox 2"/>
-          <p:cNvSpPr txBox="1"/>
-          <p:nvPr/>
-        </p:nvSpPr>
-        <p:spPr>
-          <a:xfrm>
-            <a:off x="1097280" y="1645920"/>
-            <a:ext cx="10058400" cy="1828800"/>
+            <a:off x="914400" y="2011680"/>
+            <a:ext cx="10332720" cy="1828800"/>
           </a:xfrm>
           <a:prstGeom prst="rect">
             <a:avLst/>
@@ -3169,43 +3123,16 @@
           <a:lstStyle/>
           <a:p>
             <a:pPr>
-              <a:defRPr sz="3800" b="1">
+              <a:defRPr sz="3600" b="1">
                 <a:solidFill>
                   <a:srgbClr val="F8FAFC"/>
                 </a:solidFill>
               </a:defRPr>
             </a:pPr>
             <a:r>
-              <a:t>Smart Retail &amp; Customer</a:t>
-            </a:r>
-            <a:br/>
-            <a:r>
-              <a:t>Intelligence Platform</a:t>
-            </a:r>
-          </a:p>
-        </p:txBody>
-      </p:sp>
-      <p:sp>
-        <p:nvSpPr>
-          <p:cNvPr id="4" name="TextBox 3"/>
-          <p:cNvSpPr txBox="1"/>
-          <p:nvPr/>
-        </p:nvSpPr>
-        <p:spPr>
-          <a:xfrm>
-            <a:off x="1097280" y="3474720"/>
-            <a:ext cx="10058400" cy="914400"/>
-          </a:xfrm>
-          <a:prstGeom prst="rect">
-            <a:avLst/>
-          </a:prstGeom>
-          <a:noFill/>
-        </p:spPr>
-        <p:txBody>
-          <a:bodyPr wrap="none">
-            <a:spAutoFit/>
-          </a:bodyPr>
-          <a:lstStyle/>
+              <a:t>Smart Retail &amp; Customer Intelligence Platform</a:t>
+            </a:r>
+          </a:p>
           <a:p>
             <a:pPr>
               <a:defRPr sz="1800">
@@ -3215,42 +3142,7 @@
               </a:defRPr>
             </a:pPr>
             <a:r>
-              <a:t>Live Demonstration &amp; System Walkthrough | CV, NLP, Chatbot &amp; MLOps</a:t>
-            </a:r>
-          </a:p>
-        </p:txBody>
-      </p:sp>
-      <p:sp>
-        <p:nvSpPr>
-          <p:cNvPr id="5" name="TextBox 4"/>
-          <p:cNvSpPr txBox="1"/>
-          <p:nvPr/>
-        </p:nvSpPr>
-        <p:spPr>
-          <a:xfrm>
-            <a:off x="1097280" y="5029200"/>
-            <a:ext cx="10058400" cy="914400"/>
-          </a:xfrm>
-          <a:prstGeom prst="rect">
-            <a:avLst/>
-          </a:prstGeom>
-          <a:noFill/>
-        </p:spPr>
-        <p:txBody>
-          <a:bodyPr wrap="none">
-            <a:spAutoFit/>
-          </a:bodyPr>
-          <a:lstStyle/>
-          <a:p>
-            <a:pPr>
-              <a:defRPr sz="1200">
-                <a:solidFill>
-                  <a:srgbClr val="94A3B8"/>
-                </a:solidFill>
-              </a:defRPr>
-            </a:pPr>
-            <a:r>
-              <a:t>Presenter: Shaurya | GitHub: github.com/shaurya3000/smart-retail-ai | Status: 100% Verified &amp; Tested</a:t>
+              <a:t>Live Application Demonstration Deck with Embedded UI Screenshots</a:t>
             </a:r>
           </a:p>
         </p:txBody>
@@ -3289,8 +3181,8 @@
         </p:nvSpPr>
         <p:spPr>
           <a:xfrm>
-            <a:off x="731520" y="365760"/>
-            <a:ext cx="10698480" cy="365760"/>
+            <a:off x="548640" y="365760"/>
+            <a:ext cx="10972800" cy="548640"/>
           </a:xfrm>
           <a:prstGeom prst="rect">
             <a:avLst/>
@@ -3304,270 +3196,42 @@
           <a:lstStyle/>
           <a:p>
             <a:pPr>
-              <a:defRPr sz="1100" b="1">
+              <a:defRPr sz="2200" b="1">
                 <a:solidFill>
                   <a:srgbClr val="38BDF8"/>
                 </a:solidFill>
               </a:defRPr>
             </a:pPr>
             <a:r>
-              <a:t>LIVE DEMO CAPSTONE PRESENTATION</a:t>
-            </a:r>
-          </a:p>
-        </p:txBody>
-      </p:sp>
-      <p:sp>
-        <p:nvSpPr>
-          <p:cNvPr id="3" name="TextBox 2"/>
-          <p:cNvSpPr txBox="1"/>
+              <a:t>Module A: Biometric Face Recognition &amp; Customer Visit Logger</a:t>
+            </a:r>
+          </a:p>
+        </p:txBody>
+      </p:sp>
+      <p:pic>
+        <p:nvPicPr>
+          <p:cNvPr id="3" name="Picture 2" descr="face_recognition.png"/>
+          <p:cNvPicPr>
+            <a:picLocks noChangeAspect="1"/>
+          </p:cNvPicPr>
           <p:nvPr/>
-        </p:nvSpPr>
+        </p:nvPicPr>
+        <p:blipFill>
+          <a:blip r:embed="rId2"/>
+          <a:stretch>
+            <a:fillRect/>
+          </a:stretch>
+        </p:blipFill>
         <p:spPr>
           <a:xfrm>
-            <a:off x="731520" y="640080"/>
-            <a:ext cx="10698480" cy="731520"/>
+            <a:off x="548640" y="1097280"/>
+            <a:ext cx="11091672" cy="5303520"/>
           </a:xfrm>
           <a:prstGeom prst="rect">
             <a:avLst/>
           </a:prstGeom>
-          <a:noFill/>
         </p:spPr>
-        <p:txBody>
-          <a:bodyPr wrap="none">
-            <a:spAutoFit/>
-          </a:bodyPr>
-          <a:lstStyle/>
-          <a:p>
-            <a:pPr>
-              <a:defRPr sz="2600" b="1">
-                <a:solidFill>
-                  <a:srgbClr val="F8FAFC"/>
-                </a:solidFill>
-              </a:defRPr>
-            </a:pPr>
-            <a:r>
-              <a:t>Module A: Face Recognition &amp; VIP Customer Logger</a:t>
-            </a:r>
-          </a:p>
-        </p:txBody>
-      </p:sp>
-      <p:sp>
-        <p:nvSpPr>
-          <p:cNvPr id="4" name="Rounded Rectangle 3"/>
-          <p:cNvSpPr/>
-          <p:nvPr/>
-        </p:nvSpPr>
-        <p:spPr>
-          <a:xfrm>
-            <a:off x="731520" y="1645920"/>
-            <a:ext cx="5120640" cy="4389120"/>
-          </a:xfrm>
-          <a:prstGeom prst="roundRect">
-            <a:avLst/>
-          </a:prstGeom>
-          <a:solidFill>
-            <a:srgbClr val="1E293B"/>
-          </a:solidFill>
-          <a:ln>
-            <a:solidFill>
-              <a:srgbClr val="C084FC"/>
-            </a:solidFill>
-          </a:ln>
-        </p:spPr>
-        <p:style>
-          <a:lnRef idx="1">
-            <a:schemeClr val="accent1"/>
-          </a:lnRef>
-          <a:fillRef idx="3">
-            <a:schemeClr val="accent1"/>
-          </a:fillRef>
-          <a:effectRef idx="2">
-            <a:schemeClr val="accent1"/>
-          </a:effectRef>
-          <a:fontRef idx="minor">
-            <a:schemeClr val="lt1"/>
-          </a:fontRef>
-        </p:style>
-        <p:txBody>
-          <a:bodyPr rtlCol="0" anchor="ctr" wrap="square"/>
-          <a:lstStyle/>
-          <a:p>
-            <a:pPr algn="ctr">
-              <a:defRPr sz="1800" b="1">
-                <a:solidFill>
-                  <a:srgbClr val="C084FC"/>
-                </a:solidFill>
-              </a:defRPr>
-            </a:pPr>
-            <a:r>
-              <a:t>👤 VIP Customer Recognition Demo</a:t>
-            </a:r>
-          </a:p>
-          <a:p>
-            <a:pPr>
-              <a:defRPr sz="1300">
-                <a:solidFill>
-                  <a:srgbClr val="F8FAFC"/>
-                </a:solidFill>
-              </a:defRPr>
-            </a:pPr>
-            <a:r>
-              <a:t>• Customer Profile Recognized: Bob Johnson (Platinum Loyalty Member)</a:t>
-            </a:r>
-          </a:p>
-          <a:p>
-            <a:pPr>
-              <a:defRPr sz="1300">
-                <a:solidFill>
-                  <a:srgbClr val="F8FAFC"/>
-                </a:solidFill>
-              </a:defRPr>
-            </a:pPr>
-            <a:r>
-              <a:t>• Database Matching: 128D HOG facial encoding matched against face_db.pkl (Confidence: 70.0%).</a:t>
-            </a:r>
-          </a:p>
-          <a:p>
-            <a:pPr>
-              <a:defRPr sz="1300">
-                <a:solidFill>
-                  <a:srgbClr val="F8FAFC"/>
-                </a:solidFill>
-              </a:defRPr>
-            </a:pPr>
-            <a:r>
-              <a:t>• Persistent Store Visits: Automatically incremented total store visit count to 37 visits.</a:t>
-            </a:r>
-          </a:p>
-          <a:p>
-            <a:pPr>
-              <a:defRPr sz="1300">
-                <a:solidFill>
-                  <a:srgbClr val="F8FAFC"/>
-                </a:solidFill>
-              </a:defRPr>
-            </a:pPr>
-            <a:r>
-              <a:t>• Timestamped Audit Trail: Last visit logged at 2026-08-03 21:29:01.</a:t>
-            </a:r>
-          </a:p>
-          <a:p>
-            <a:pPr>
-              <a:defRPr sz="1300">
-                <a:solidFill>
-                  <a:srgbClr val="F8FAFC"/>
-                </a:solidFill>
-              </a:defRPr>
-            </a:pPr>
-            <a:r>
-              <a:t>• Biometric Privacy Consent: Consent Granted = TRUE (GDPR/CCPA compliant).</a:t>
-            </a:r>
-          </a:p>
-        </p:txBody>
-      </p:sp>
-      <p:sp>
-        <p:nvSpPr>
-          <p:cNvPr id="5" name="Rounded Rectangle 4"/>
-          <p:cNvSpPr/>
-          <p:nvPr/>
-        </p:nvSpPr>
-        <p:spPr>
-          <a:xfrm>
-            <a:off x="6217920" y="1645920"/>
-            <a:ext cx="5212080" cy="4389120"/>
-          </a:xfrm>
-          <a:prstGeom prst="roundRect">
-            <a:avLst/>
-          </a:prstGeom>
-          <a:solidFill>
-            <a:srgbClr val="1E293B"/>
-          </a:solidFill>
-          <a:ln>
-            <a:solidFill>
-              <a:srgbClr val="38BDF8"/>
-            </a:solidFill>
-          </a:ln>
-        </p:spPr>
-        <p:style>
-          <a:lnRef idx="1">
-            <a:schemeClr val="accent1"/>
-          </a:lnRef>
-          <a:fillRef idx="3">
-            <a:schemeClr val="accent1"/>
-          </a:fillRef>
-          <a:effectRef idx="2">
-            <a:schemeClr val="accent1"/>
-          </a:effectRef>
-          <a:fontRef idx="minor">
-            <a:schemeClr val="lt1"/>
-          </a:fontRef>
-        </p:style>
-        <p:txBody>
-          <a:bodyPr rtlCol="0" anchor="ctr" wrap="square"/>
-          <a:lstStyle/>
-          <a:p>
-            <a:pPr algn="ctr">
-              <a:defRPr sz="1800" b="1">
-                <a:solidFill>
-                  <a:srgbClr val="38BDF8"/>
-                </a:solidFill>
-              </a:defRPr>
-            </a:pPr>
-            <a:r>
-              <a:t>📄 System JSON API Response</a:t>
-            </a:r>
-          </a:p>
-          <a:p>
-            <a:pPr>
-              <a:defRPr sz="1300">
-                <a:solidFill>
-                  <a:srgbClr val="34D399"/>
-                </a:solidFill>
-                <a:latin typeface="Courier New"/>
-              </a:defRPr>
-            </a:pPr>
-            <a:r>
-              <a:t>{</a:t>
-            </a:r>
-            <a:br/>
-            <a:r>
-              <a:t>  "Status" : "recognized",</a:t>
-            </a:r>
-            <a:br/>
-            <a:r>
-              <a:t>  "Customer ID" : "CUST_1002",</a:t>
-            </a:r>
-            <a:br/>
-            <a:r>
-              <a:t>  "Name" : "Bob Johnson",</a:t>
-            </a:r>
-            <a:br/>
-            <a:r>
-              <a:t>  "Loyalty Tier" : "Platinum",</a:t>
-            </a:r>
-            <a:br/>
-            <a:r>
-              <a:t>  "Recognition Confidence" : "70.0%",</a:t>
-            </a:r>
-            <a:br/>
-            <a:r>
-              <a:t>  "Total Store Visits" : 37,</a:t>
-            </a:r>
-            <a:br/>
-            <a:r>
-              <a:t>  "Last Visit Timestamp" : "2026-08-03 21:29:01",</a:t>
-            </a:r>
-            <a:br/>
-            <a:r>
-              <a:t>  "Biometric Consent Granted" : true</a:t>
-            </a:r>
-            <a:br/>
-            <a:r>
-              <a:t>}</a:t>
-            </a:r>
-          </a:p>
-        </p:txBody>
-      </p:sp>
+      </p:pic>
     </p:spTree>
   </p:cSld>
   <p:clrMapOvr>
@@ -3602,8 +3266,8 @@
         </p:nvSpPr>
         <p:spPr>
           <a:xfrm>
-            <a:off x="731520" y="365760"/>
-            <a:ext cx="10698480" cy="365760"/>
+            <a:off x="548640" y="365760"/>
+            <a:ext cx="10972800" cy="548640"/>
           </a:xfrm>
           <a:prstGeom prst="rect">
             <a:avLst/>
@@ -3617,269 +3281,42 @@
           <a:lstStyle/>
           <a:p>
             <a:pPr>
-              <a:defRPr sz="1100" b="1">
+              <a:defRPr sz="2200" b="1">
                 <a:solidFill>
                   <a:srgbClr val="38BDF8"/>
                 </a:solidFill>
               </a:defRPr>
             </a:pPr>
             <a:r>
-              <a:t>LIVE DEMO CAPSTONE PRESENTATION</a:t>
-            </a:r>
-          </a:p>
-        </p:txBody>
-      </p:sp>
-      <p:sp>
-        <p:nvSpPr>
-          <p:cNvPr id="3" name="TextBox 2"/>
-          <p:cNvSpPr txBox="1"/>
+              <a:t>Module B: Customer Feedback Sentiment Analysis NLP Engine</a:t>
+            </a:r>
+          </a:p>
+        </p:txBody>
+      </p:sp>
+      <p:pic>
+        <p:nvPicPr>
+          <p:cNvPr id="3" name="Picture 2" descr="sentiment_analysis_2.png"/>
+          <p:cNvPicPr>
+            <a:picLocks noChangeAspect="1"/>
+          </p:cNvPicPr>
           <p:nvPr/>
-        </p:nvSpPr>
+        </p:nvPicPr>
+        <p:blipFill>
+          <a:blip r:embed="rId2"/>
+          <a:stretch>
+            <a:fillRect/>
+          </a:stretch>
+        </p:blipFill>
         <p:spPr>
           <a:xfrm>
-            <a:off x="731520" y="640080"/>
-            <a:ext cx="10698480" cy="731520"/>
+            <a:off x="548640" y="1097280"/>
+            <a:ext cx="11091672" cy="5303520"/>
           </a:xfrm>
           <a:prstGeom prst="rect">
             <a:avLst/>
           </a:prstGeom>
-          <a:noFill/>
         </p:spPr>
-        <p:txBody>
-          <a:bodyPr wrap="none">
-            <a:spAutoFit/>
-          </a:bodyPr>
-          <a:lstStyle/>
-          <a:p>
-            <a:pPr>
-              <a:defRPr sz="2600" b="1">
-                <a:solidFill>
-                  <a:srgbClr val="F8FAFC"/>
-                </a:solidFill>
-              </a:defRPr>
-            </a:pPr>
-            <a:r>
-              <a:t>Module A: Deep Learning Product Category Classifier</a:t>
-            </a:r>
-          </a:p>
-        </p:txBody>
-      </p:sp>
-      <p:sp>
-        <p:nvSpPr>
-          <p:cNvPr id="4" name="Rounded Rectangle 3"/>
-          <p:cNvSpPr/>
-          <p:nvPr/>
-        </p:nvSpPr>
-        <p:spPr>
-          <a:xfrm>
-            <a:off x="731520" y="1645920"/>
-            <a:ext cx="5120640" cy="4389120"/>
-          </a:xfrm>
-          <a:prstGeom prst="roundRect">
-            <a:avLst/>
-          </a:prstGeom>
-          <a:solidFill>
-            <a:srgbClr val="1E293B"/>
-          </a:solidFill>
-          <a:ln>
-            <a:solidFill>
-              <a:srgbClr val="38BDF8"/>
-            </a:solidFill>
-          </a:ln>
-        </p:spPr>
-        <p:style>
-          <a:lnRef idx="1">
-            <a:schemeClr val="accent1"/>
-          </a:lnRef>
-          <a:fillRef idx="3">
-            <a:schemeClr val="accent1"/>
-          </a:fillRef>
-          <a:effectRef idx="2">
-            <a:schemeClr val="accent1"/>
-          </a:effectRef>
-          <a:fontRef idx="minor">
-            <a:schemeClr val="lt1"/>
-          </a:fontRef>
-        </p:style>
-        <p:txBody>
-          <a:bodyPr rtlCol="0" anchor="ctr" wrap="square"/>
-          <a:lstStyle/>
-          <a:p>
-            <a:pPr algn="ctr">
-              <a:defRPr sz="1800" b="1">
-                <a:solidFill>
-                  <a:srgbClr val="38BDF8"/>
-                </a:solidFill>
-              </a:defRPr>
-            </a:pPr>
-            <a:r>
-              <a:t>🛍️ PyTorch MobileNetV2 Architecture</a:t>
-            </a:r>
-          </a:p>
-          <a:p>
-            <a:pPr>
-              <a:defRPr sz="1300">
-                <a:solidFill>
-                  <a:srgbClr val="F8FAFC"/>
-                </a:solidFill>
-              </a:defRPr>
-            </a:pPr>
-            <a:r>
-              <a:t>• Deep Transfer Learning: Evaluates 1,000 ImageNet synset activations to predict 5 core retail categories.</a:t>
-            </a:r>
-          </a:p>
-          <a:p>
-            <a:pPr>
-              <a:defRPr sz="1300">
-                <a:solidFill>
-                  <a:srgbClr val="F8FAFC"/>
-                </a:solidFill>
-              </a:defRPr>
-            </a:pPr>
-            <a:r>
-              <a:t>• Supported Categories: Groceries 🥦, Electronics 💻, Shoes 👟, Clothing 👕, Bags 🎒.</a:t>
-            </a:r>
-          </a:p>
-          <a:p>
-            <a:pPr>
-              <a:defRPr sz="1300">
-                <a:solidFill>
-                  <a:srgbClr val="F8FAFC"/>
-                </a:solidFill>
-              </a:defRPr>
-            </a:pPr>
-            <a:r>
-              <a:t>• High Precision Accuracy: Delivers 95%+ confidence probability breakdown across diverse product uploads.</a:t>
-            </a:r>
-          </a:p>
-          <a:p>
-            <a:pPr>
-              <a:defRPr sz="1300">
-                <a:solidFill>
-                  <a:srgbClr val="F8FAFC"/>
-                </a:solidFill>
-              </a:defRPr>
-            </a:pPr>
-            <a:r>
-              <a:t>• Zero Rule Overfitting: Pure deep learning inference without fragile manual overrides.</a:t>
-            </a:r>
-          </a:p>
-        </p:txBody>
-      </p:sp>
-      <p:sp>
-        <p:nvSpPr>
-          <p:cNvPr id="5" name="Rounded Rectangle 4"/>
-          <p:cNvSpPr/>
-          <p:nvPr/>
-        </p:nvSpPr>
-        <p:spPr>
-          <a:xfrm>
-            <a:off x="6217920" y="1645920"/>
-            <a:ext cx="5212080" cy="4389120"/>
-          </a:xfrm>
-          <a:prstGeom prst="roundRect">
-            <a:avLst/>
-          </a:prstGeom>
-          <a:solidFill>
-            <a:srgbClr val="1E293B"/>
-          </a:solidFill>
-          <a:ln>
-            <a:solidFill>
-              <a:srgbClr val="34D399"/>
-            </a:solidFill>
-          </a:ln>
-        </p:spPr>
-        <p:style>
-          <a:lnRef idx="1">
-            <a:schemeClr val="accent1"/>
-          </a:lnRef>
-          <a:fillRef idx="3">
-            <a:schemeClr val="accent1"/>
-          </a:fillRef>
-          <a:effectRef idx="2">
-            <a:schemeClr val="accent1"/>
-          </a:effectRef>
-          <a:fontRef idx="minor">
-            <a:schemeClr val="lt1"/>
-          </a:fontRef>
-        </p:style>
-        <p:txBody>
-          <a:bodyPr rtlCol="0" anchor="ctr" wrap="square"/>
-          <a:lstStyle/>
-          <a:p>
-            <a:pPr algn="ctr">
-              <a:defRPr sz="1800" b="1">
-                <a:solidFill>
-                  <a:srgbClr val="34D399"/>
-                </a:solidFill>
-              </a:defRPr>
-            </a:pPr>
-            <a:r>
-              <a:t>⚡ Live Classification Benchmarks</a:t>
-            </a:r>
-          </a:p>
-          <a:p>
-            <a:pPr>
-              <a:defRPr sz="1300">
-                <a:solidFill>
-                  <a:srgbClr val="F8FAFC"/>
-                </a:solidFill>
-              </a:defRPr>
-            </a:pPr>
-            <a:r>
-              <a:t>✔ Grocery Shelves / Produce -&gt; GROCERIES (95.0%)</a:t>
-            </a:r>
-          </a:p>
-          <a:p>
-            <a:pPr>
-              <a:defRPr sz="1300">
-                <a:solidFill>
-                  <a:srgbClr val="F8FAFC"/>
-                </a:solidFill>
-              </a:defRPr>
-            </a:pPr>
-            <a:r>
-              <a:t>✔ MacBooks &amp; Laptops -&gt; ELECTRONICS (95.0%)</a:t>
-            </a:r>
-          </a:p>
-          <a:p>
-            <a:pPr>
-              <a:defRPr sz="1300">
-                <a:solidFill>
-                  <a:srgbClr val="F8FAFC"/>
-                </a:solidFill>
-              </a:defRPr>
-            </a:pPr>
-            <a:r>
-              <a:t>✔ Sneakers &amp; Footwear -&gt; SHOES (94.0%)</a:t>
-            </a:r>
-          </a:p>
-          <a:p>
-            <a:pPr>
-              <a:defRPr sz="1300">
-                <a:solidFill>
-                  <a:srgbClr val="F8FAFC"/>
-                </a:solidFill>
-              </a:defRPr>
-            </a:pPr>
-            <a:r>
-              <a:t>✔ Flat-Lay Garments &amp; Apparel -&gt; CLOTHING (93.0%)</a:t>
-            </a:r>
-          </a:p>
-          <a:p>
-            <a:pPr>
-              <a:defRPr sz="1300">
-                <a:solidFill>
-                  <a:srgbClr val="F8FAFC"/>
-                </a:solidFill>
-              </a:defRPr>
-            </a:pPr>
-            <a:r>
-              <a:t>✔ Handbags &amp; Backpacks -&gt; BAGS (92.0%)</a:t>
-            </a:r>
-          </a:p>
-        </p:txBody>
-      </p:sp>
+      </p:pic>
     </p:spTree>
   </p:cSld>
   <p:clrMapOvr>
@@ -3914,8 +3351,8 @@
         </p:nvSpPr>
         <p:spPr>
           <a:xfrm>
-            <a:off x="731520" y="365760"/>
-            <a:ext cx="10698480" cy="365760"/>
+            <a:off x="548640" y="365760"/>
+            <a:ext cx="10972800" cy="548640"/>
           </a:xfrm>
           <a:prstGeom prst="rect">
             <a:avLst/>
@@ -3929,281 +3366,42 @@
           <a:lstStyle/>
           <a:p>
             <a:pPr>
-              <a:defRPr sz="1100" b="1">
+              <a:defRPr sz="2200" b="1">
                 <a:solidFill>
                   <a:srgbClr val="38BDF8"/>
                 </a:solidFill>
               </a:defRPr>
             </a:pPr>
             <a:r>
-              <a:t>LIVE DEMO CAPSTONE PRESENTATION</a:t>
-            </a:r>
-          </a:p>
-        </p:txBody>
-      </p:sp>
-      <p:sp>
-        <p:nvSpPr>
-          <p:cNvPr id="3" name="TextBox 2"/>
-          <p:cNvSpPr txBox="1"/>
+              <a:t>Module B: AI Retail Customer Support Assistant</a:t>
+            </a:r>
+          </a:p>
+        </p:txBody>
+      </p:sp>
+      <p:pic>
+        <p:nvPicPr>
+          <p:cNvPr id="3" name="Picture 2" descr="chatbot_assistant.png"/>
+          <p:cNvPicPr>
+            <a:picLocks noChangeAspect="1"/>
+          </p:cNvPicPr>
           <p:nvPr/>
-        </p:nvSpPr>
+        </p:nvPicPr>
+        <p:blipFill>
+          <a:blip r:embed="rId2"/>
+          <a:stretch>
+            <a:fillRect/>
+          </a:stretch>
+        </p:blipFill>
         <p:spPr>
           <a:xfrm>
-            <a:off x="731520" y="640080"/>
-            <a:ext cx="10698480" cy="731520"/>
+            <a:off x="548640" y="1097280"/>
+            <a:ext cx="11091672" cy="5303520"/>
           </a:xfrm>
           <a:prstGeom prst="rect">
             <a:avLst/>
           </a:prstGeom>
-          <a:noFill/>
         </p:spPr>
-        <p:txBody>
-          <a:bodyPr wrap="none">
-            <a:spAutoFit/>
-          </a:bodyPr>
-          <a:lstStyle/>
-          <a:p>
-            <a:pPr>
-              <a:defRPr sz="2600" b="1">
-                <a:solidFill>
-                  <a:srgbClr val="F8FAFC"/>
-                </a:solidFill>
-              </a:defRPr>
-            </a:pPr>
-            <a:r>
-              <a:t>Module B: Customer Feedback Sentiment NLP Engine</a:t>
-            </a:r>
-          </a:p>
-        </p:txBody>
-      </p:sp>
-      <p:sp>
-        <p:nvSpPr>
-          <p:cNvPr id="4" name="Rounded Rectangle 3"/>
-          <p:cNvSpPr/>
-          <p:nvPr/>
-        </p:nvSpPr>
-        <p:spPr>
-          <a:xfrm>
-            <a:off x="731520" y="1645920"/>
-            <a:ext cx="5120640" cy="4389120"/>
-          </a:xfrm>
-          <a:prstGeom prst="roundRect">
-            <a:avLst/>
-          </a:prstGeom>
-          <a:solidFill>
-            <a:srgbClr val="1E293B"/>
-          </a:solidFill>
-          <a:ln>
-            <a:solidFill>
-              <a:srgbClr val="34D399"/>
-            </a:solidFill>
-          </a:ln>
-        </p:spPr>
-        <p:style>
-          <a:lnRef idx="1">
-            <a:schemeClr val="accent1"/>
-          </a:lnRef>
-          <a:fillRef idx="3">
-            <a:schemeClr val="accent1"/>
-          </a:fillRef>
-          <a:effectRef idx="2">
-            <a:schemeClr val="accent1"/>
-          </a:effectRef>
-          <a:fontRef idx="minor">
-            <a:schemeClr val="lt1"/>
-          </a:fontRef>
-        </p:style>
-        <p:txBody>
-          <a:bodyPr rtlCol="0" anchor="ctr" wrap="square"/>
-          <a:lstStyle/>
-          <a:p>
-            <a:pPr algn="ctr">
-              <a:defRPr sz="1800" b="1">
-                <a:solidFill>
-                  <a:srgbClr val="34D399"/>
-                </a:solidFill>
-              </a:defRPr>
-            </a:pPr>
-            <a:r>
-              <a:t>💬 Customer Review Analysis Demo 1</a:t>
-            </a:r>
-          </a:p>
-          <a:p>
-            <a:pPr>
-              <a:defRPr sz="1300">
-                <a:solidFill>
-                  <a:srgbClr val="F8FAFC"/>
-                </a:solidFill>
-              </a:defRPr>
-            </a:pPr>
-            <a:r>
-              <a:t>• Review Input: 'I love shopping at this store! Fast delivery and great prices.'</a:t>
-            </a:r>
-          </a:p>
-          <a:p>
-            <a:pPr>
-              <a:defRPr sz="1300">
-                <a:solidFill>
-                  <a:srgbClr val="F8FAFC"/>
-                </a:solidFill>
-              </a:defRPr>
-            </a:pPr>
-            <a:r>
-              <a:t>• Cleaned Tokens: 'love shopping store fast delivery great prices'</a:t>
-            </a:r>
-          </a:p>
-          <a:p>
-            <a:pPr>
-              <a:defRPr sz="1300">
-                <a:solidFill>
-                  <a:srgbClr val="F8FAFC"/>
-                </a:solidFill>
-              </a:defRPr>
-            </a:pPr>
-            <a:r>
-              <a:t>• Predicted Sentiment: POSITIVE 😄</a:t>
-            </a:r>
-          </a:p>
-          <a:p>
-            <a:pPr>
-              <a:defRPr sz="1300">
-                <a:solidFill>
-                  <a:srgbClr val="F8FAFC"/>
-                </a:solidFill>
-              </a:defRPr>
-            </a:pPr>
-            <a:r>
-              <a:t>• Confidence Score: 77.4%</a:t>
-            </a:r>
-          </a:p>
-          <a:p>
-            <a:pPr>
-              <a:defRPr sz="1300">
-                <a:solidFill>
-                  <a:srgbClr val="F8FAFC"/>
-                </a:solidFill>
-              </a:defRPr>
-            </a:pPr>
-            <a:r>
-              <a:t>• Tokenization &amp; Stopword Filtering: Removes low-information words while preserving high-impact descriptors.</a:t>
-            </a:r>
-          </a:p>
-        </p:txBody>
-      </p:sp>
-      <p:sp>
-        <p:nvSpPr>
-          <p:cNvPr id="5" name="Rounded Rectangle 4"/>
-          <p:cNvSpPr/>
-          <p:nvPr/>
-        </p:nvSpPr>
-        <p:spPr>
-          <a:xfrm>
-            <a:off x="6217920" y="1645920"/>
-            <a:ext cx="5212080" cy="4389120"/>
-          </a:xfrm>
-          <a:prstGeom prst="roundRect">
-            <a:avLst/>
-          </a:prstGeom>
-          <a:solidFill>
-            <a:srgbClr val="1E293B"/>
-          </a:solidFill>
-          <a:ln>
-            <a:solidFill>
-              <a:srgbClr val="38BDF8"/>
-            </a:solidFill>
-          </a:ln>
-        </p:spPr>
-        <p:style>
-          <a:lnRef idx="1">
-            <a:schemeClr val="accent1"/>
-          </a:lnRef>
-          <a:fillRef idx="3">
-            <a:schemeClr val="accent1"/>
-          </a:fillRef>
-          <a:effectRef idx="2">
-            <a:schemeClr val="accent1"/>
-          </a:effectRef>
-          <a:fontRef idx="minor">
-            <a:schemeClr val="lt1"/>
-          </a:fontRef>
-        </p:style>
-        <p:txBody>
-          <a:bodyPr rtlCol="0" anchor="ctr" wrap="square"/>
-          <a:lstStyle/>
-          <a:p>
-            <a:pPr algn="ctr">
-              <a:defRPr sz="1800" b="1">
-                <a:solidFill>
-                  <a:srgbClr val="38BDF8"/>
-                </a:solidFill>
-              </a:defRPr>
-            </a:pPr>
-            <a:r>
-              <a:t>⚡ Calibrated High-Confidence Demo 2</a:t>
-            </a:r>
-          </a:p>
-          <a:p>
-            <a:pPr>
-              <a:defRPr sz="1300">
-                <a:solidFill>
-                  <a:srgbClr val="F8FAFC"/>
-                </a:solidFill>
-              </a:defRPr>
-            </a:pPr>
-            <a:r>
-              <a:t>• Review Input: 'The quality of this leather jacket is exceptional. Super comfortable and stylish!'</a:t>
-            </a:r>
-          </a:p>
-          <a:p>
-            <a:pPr>
-              <a:defRPr sz="1300">
-                <a:solidFill>
-                  <a:srgbClr val="F8FAFC"/>
-                </a:solidFill>
-              </a:defRPr>
-            </a:pPr>
-            <a:r>
-              <a:t>• Cleaned Tokens: 'quality leather jacket exceptional super comfortable stylish'</a:t>
-            </a:r>
-          </a:p>
-          <a:p>
-            <a:pPr>
-              <a:defRPr sz="1300">
-                <a:solidFill>
-                  <a:srgbClr val="F8FAFC"/>
-                </a:solidFill>
-              </a:defRPr>
-            </a:pPr>
-            <a:r>
-              <a:t>• Predicted Sentiment: POSITIVE 😄</a:t>
-            </a:r>
-          </a:p>
-          <a:p>
-            <a:pPr>
-              <a:defRPr sz="1300">
-                <a:solidFill>
-                  <a:srgbClr val="F8FAFC"/>
-                </a:solidFill>
-              </a:defRPr>
-            </a:pPr>
-            <a:r>
-              <a:t>• Confidence Score: 88.2%</a:t>
-            </a:r>
-          </a:p>
-          <a:p>
-            <a:pPr>
-              <a:defRPr sz="1300">
-                <a:solidFill>
-                  <a:srgbClr val="F8FAFC"/>
-                </a:solidFill>
-              </a:defRPr>
-            </a:pPr>
-            <a:r>
-              <a:t>• Softmax Temperature Scaling: Calibrates class probabilities to reflect sharp confidence for strongly opinionated reviews.</a:t>
-            </a:r>
-          </a:p>
-        </p:txBody>
-      </p:sp>
+      </p:pic>
     </p:spTree>
   </p:cSld>
   <p:clrMapOvr>
@@ -4238,8 +3436,8 @@
         </p:nvSpPr>
         <p:spPr>
           <a:xfrm>
-            <a:off x="731520" y="365760"/>
-            <a:ext cx="10698480" cy="365760"/>
+            <a:off x="548640" y="365760"/>
+            <a:ext cx="10972800" cy="548640"/>
           </a:xfrm>
           <a:prstGeom prst="rect">
             <a:avLst/>
@@ -4253,395 +3451,6 @@
           <a:lstStyle/>
           <a:p>
             <a:pPr>
-              <a:defRPr sz="1100" b="1">
-                <a:solidFill>
-                  <a:srgbClr val="38BDF8"/>
-                </a:solidFill>
-              </a:defRPr>
-            </a:pPr>
-            <a:r>
-              <a:t>LIVE DEMO CAPSTONE PRESENTATION</a:t>
-            </a:r>
-          </a:p>
-        </p:txBody>
-      </p:sp>
-      <p:sp>
-        <p:nvSpPr>
-          <p:cNvPr id="3" name="TextBox 2"/>
-          <p:cNvSpPr txBox="1"/>
-          <p:nvPr/>
-        </p:nvSpPr>
-        <p:spPr>
-          <a:xfrm>
-            <a:off x="731520" y="640080"/>
-            <a:ext cx="10698480" cy="731520"/>
-          </a:xfrm>
-          <a:prstGeom prst="rect">
-            <a:avLst/>
-          </a:prstGeom>
-          <a:noFill/>
-        </p:spPr>
-        <p:txBody>
-          <a:bodyPr wrap="none">
-            <a:spAutoFit/>
-          </a:bodyPr>
-          <a:lstStyle/>
-          <a:p>
-            <a:pPr>
-              <a:defRPr sz="2600" b="1">
-                <a:solidFill>
-                  <a:srgbClr val="F8FAFC"/>
-                </a:solidFill>
-              </a:defRPr>
-            </a:pPr>
-            <a:r>
-              <a:t>Module B: AI Retail Customer Support Assistant</a:t>
-            </a:r>
-          </a:p>
-        </p:txBody>
-      </p:sp>
-      <p:sp>
-        <p:nvSpPr>
-          <p:cNvPr id="4" name="Rounded Rectangle 3"/>
-          <p:cNvSpPr/>
-          <p:nvPr/>
-        </p:nvSpPr>
-        <p:spPr>
-          <a:xfrm>
-            <a:off x="731520" y="1645920"/>
-            <a:ext cx="5120640" cy="4389120"/>
-          </a:xfrm>
-          <a:prstGeom prst="roundRect">
-            <a:avLst/>
-          </a:prstGeom>
-          <a:solidFill>
-            <a:srgbClr val="1E293B"/>
-          </a:solidFill>
-          <a:ln>
-            <a:solidFill>
-              <a:srgbClr val="C084FC"/>
-            </a:solidFill>
-          </a:ln>
-        </p:spPr>
-        <p:style>
-          <a:lnRef idx="1">
-            <a:schemeClr val="accent1"/>
-          </a:lnRef>
-          <a:fillRef idx="3">
-            <a:schemeClr val="accent1"/>
-          </a:fillRef>
-          <a:effectRef idx="2">
-            <a:schemeClr val="accent1"/>
-          </a:effectRef>
-          <a:fontRef idx="minor">
-            <a:schemeClr val="lt1"/>
-          </a:fontRef>
-        </p:style>
-        <p:txBody>
-          <a:bodyPr rtlCol="0" anchor="ctr" wrap="square"/>
-          <a:lstStyle/>
-          <a:p>
-            <a:pPr algn="ctr">
-              <a:defRPr sz="1800" b="1">
-                <a:solidFill>
-                  <a:srgbClr val="C084FC"/>
-                </a:solidFill>
-              </a:defRPr>
-            </a:pPr>
-            <a:r>
-              <a:t>🤖 Live Chat Session Demonstration</a:t>
-            </a:r>
-          </a:p>
-          <a:p>
-            <a:pPr>
-              <a:defRPr sz="1300">
-                <a:solidFill>
-                  <a:srgbClr val="F8FAFC"/>
-                </a:solidFill>
-              </a:defRPr>
-            </a:pPr>
-            <a:r>
-              <a:t>• User Prompt: 'Where is my order?'</a:t>
-            </a:r>
-          </a:p>
-          <a:p>
-            <a:pPr>
-              <a:defRPr sz="1300">
-                <a:solidFill>
-                  <a:srgbClr val="F8FAFC"/>
-                </a:solidFill>
-              </a:defRPr>
-            </a:pPr>
-            <a:r>
-              <a:t>• Bot Reply: 'You can track your order status in real time under My Orders portal or by entering your 8-digit Order Number.'</a:t>
-            </a:r>
-          </a:p>
-          <a:p>
-            <a:pPr>
-              <a:defRPr sz="1300">
-                <a:solidFill>
-                  <a:srgbClr val="F8FAFC"/>
-                </a:solidFill>
-              </a:defRPr>
-            </a:pPr>
-            <a:r>
-              <a:t>• Execution Strategy: Rule-Based FAQ Match</a:t>
-            </a:r>
-          </a:p>
-          <a:p>
-            <a:pPr>
-              <a:defRPr sz="1300">
-                <a:solidFill>
-                  <a:srgbClr val="F8FAFC"/>
-                </a:solidFill>
-              </a:defRPr>
-            </a:pPr>
-            <a:r>
-              <a:t>• Matched Intent Tag: order_status</a:t>
-            </a:r>
-          </a:p>
-          <a:p>
-            <a:pPr>
-              <a:defRPr sz="1300">
-                <a:solidFill>
-                  <a:srgbClr val="F8FAFC"/>
-                </a:solidFill>
-              </a:defRPr>
-            </a:pPr>
-            <a:r>
-              <a:t>• Confidence Score: 99%</a:t>
-            </a:r>
-          </a:p>
-        </p:txBody>
-      </p:sp>
-      <p:sp>
-        <p:nvSpPr>
-          <p:cNvPr id="5" name="Rounded Rectangle 4"/>
-          <p:cNvSpPr/>
-          <p:nvPr/>
-        </p:nvSpPr>
-        <p:spPr>
-          <a:xfrm>
-            <a:off x="6217920" y="1645920"/>
-            <a:ext cx="5212080" cy="4389120"/>
-          </a:xfrm>
-          <a:prstGeom prst="roundRect">
-            <a:avLst/>
-          </a:prstGeom>
-          <a:solidFill>
-            <a:srgbClr val="1E293B"/>
-          </a:solidFill>
-          <a:ln>
-            <a:solidFill>
-              <a:srgbClr val="34D399"/>
-            </a:solidFill>
-          </a:ln>
-        </p:spPr>
-        <p:style>
-          <a:lnRef idx="1">
-            <a:schemeClr val="accent1"/>
-          </a:lnRef>
-          <a:fillRef idx="3">
-            <a:schemeClr val="accent1"/>
-          </a:fillRef>
-          <a:effectRef idx="2">
-            <a:schemeClr val="accent1"/>
-          </a:effectRef>
-          <a:fontRef idx="minor">
-            <a:schemeClr val="lt1"/>
-          </a:fontRef>
-        </p:style>
-        <p:txBody>
-          <a:bodyPr rtlCol="0" anchor="ctr" wrap="square"/>
-          <a:lstStyle/>
-          <a:p>
-            <a:pPr algn="ctr">
-              <a:defRPr sz="1800" b="1">
-                <a:solidFill>
-                  <a:srgbClr val="34D399"/>
-                </a:solidFill>
-              </a:defRPr>
-            </a:pPr>
-            <a:r>
-              <a:t>🎯 Dual-Phase Hybrid Engine</a:t>
-            </a:r>
-          </a:p>
-          <a:p>
-            <a:pPr>
-              <a:defRPr sz="1300">
-                <a:solidFill>
-                  <a:srgbClr val="F8FAFC"/>
-                </a:solidFill>
-              </a:defRPr>
-            </a:pPr>
-            <a:r>
-              <a:t>• Phase 1 - Rule-Based Matcher: Instant 0.99 confidence response for top retail FAQs (orders, returns, store hours, shipping, payment).</a:t>
-            </a:r>
-          </a:p>
-          <a:p>
-            <a:pPr>
-              <a:defRPr sz="1300">
-                <a:solidFill>
-                  <a:srgbClr val="F8FAFC"/>
-                </a:solidFill>
-              </a:defRPr>
-            </a:pPr>
-            <a:r>
-              <a:t>• Phase 2 - ML Fallback Classifier: TF-IDF + Logistic Regression model trained on 20+ intent categories for natural language variations.</a:t>
-            </a:r>
-          </a:p>
-          <a:p>
-            <a:pPr>
-              <a:defRPr sz="1300">
-                <a:solidFill>
-                  <a:srgbClr val="F8FAFC"/>
-                </a:solidFill>
-              </a:defRPr>
-            </a:pPr>
-            <a:r>
-              <a:t>• Live Human Agent Escalation: Route session to support agent upon request.</a:t>
-            </a:r>
-          </a:p>
-        </p:txBody>
-      </p:sp>
-    </p:spTree>
-  </p:cSld>
-  <p:clrMapOvr>
-    <a:masterClrMapping/>
-  </p:clrMapOvr>
-</p:sld>
-</file>
-
-<file path=ppt/slides/slide6.xml><?xml version="1.0" encoding="utf-8"?>
-<p:sld xmlns:a="http://schemas.openxmlformats.org/drawingml/2006/main" xmlns:p="http://schemas.openxmlformats.org/presentationml/2006/main" xmlns:r="http://schemas.openxmlformats.org/officeDocument/2006/relationships">
-  <p:cSld>
-    <p:bg>
-      <p:bgPr>
-        <a:solidFill>
-          <a:srgbClr val="0F172A"/>
-        </a:solidFill>
-        <a:effectLst/>
-      </p:bgPr>
-    </p:bg>
-    <p:spTree>
-      <p:nvGrpSpPr>
-        <p:cNvPr id="1" name=""/>
-        <p:cNvGrpSpPr/>
-        <p:nvPr/>
-      </p:nvGrpSpPr>
-      <p:grpSpPr/>
-      <p:sp>
-        <p:nvSpPr>
-          <p:cNvPr id="2" name="TextBox 1"/>
-          <p:cNvSpPr txBox="1"/>
-          <p:nvPr/>
-        </p:nvSpPr>
-        <p:spPr>
-          <a:xfrm>
-            <a:off x="731520" y="365760"/>
-            <a:ext cx="10698480" cy="365760"/>
-          </a:xfrm>
-          <a:prstGeom prst="rect">
-            <a:avLst/>
-          </a:prstGeom>
-          <a:noFill/>
-        </p:spPr>
-        <p:txBody>
-          <a:bodyPr wrap="none">
-            <a:spAutoFit/>
-          </a:bodyPr>
-          <a:lstStyle/>
-          <a:p>
-            <a:pPr>
-              <a:defRPr sz="1100" b="1">
-                <a:solidFill>
-                  <a:srgbClr val="38BDF8"/>
-                </a:solidFill>
-              </a:defRPr>
-            </a:pPr>
-            <a:r>
-              <a:t>LIVE DEMO CAPSTONE PRESENTATION</a:t>
-            </a:r>
-          </a:p>
-        </p:txBody>
-      </p:sp>
-      <p:sp>
-        <p:nvSpPr>
-          <p:cNvPr id="3" name="TextBox 2"/>
-          <p:cNvSpPr txBox="1"/>
-          <p:nvPr/>
-        </p:nvSpPr>
-        <p:spPr>
-          <a:xfrm>
-            <a:off x="731520" y="640080"/>
-            <a:ext cx="10698480" cy="731520"/>
-          </a:xfrm>
-          <a:prstGeom prst="rect">
-            <a:avLst/>
-          </a:prstGeom>
-          <a:noFill/>
-        </p:spPr>
-        <p:txBody>
-          <a:bodyPr wrap="none">
-            <a:spAutoFit/>
-          </a:bodyPr>
-          <a:lstStyle/>
-          <a:p>
-            <a:pPr>
-              <a:defRPr sz="2600" b="1">
-                <a:solidFill>
-                  <a:srgbClr val="F8FAFC"/>
-                </a:solidFill>
-              </a:defRPr>
-            </a:pPr>
-            <a:r>
-              <a:t>Module C: Executive Retail Intelligence &amp; Telemetry</a:t>
-            </a:r>
-          </a:p>
-        </p:txBody>
-      </p:sp>
-      <p:sp>
-        <p:nvSpPr>
-          <p:cNvPr id="4" name="Rounded Rectangle 3"/>
-          <p:cNvSpPr/>
-          <p:nvPr/>
-        </p:nvSpPr>
-        <p:spPr>
-          <a:xfrm>
-            <a:off x="731520" y="1645920"/>
-            <a:ext cx="2468880" cy="1097280"/>
-          </a:xfrm>
-          <a:prstGeom prst="roundRect">
-            <a:avLst/>
-          </a:prstGeom>
-          <a:solidFill>
-            <a:srgbClr val="1E293B"/>
-          </a:solidFill>
-          <a:ln>
-            <a:solidFill>
-              <a:srgbClr val="38BDF8"/>
-            </a:solidFill>
-          </a:ln>
-        </p:spPr>
-        <p:style>
-          <a:lnRef idx="1">
-            <a:schemeClr val="accent1"/>
-          </a:lnRef>
-          <a:fillRef idx="3">
-            <a:schemeClr val="accent1"/>
-          </a:fillRef>
-          <a:effectRef idx="2">
-            <a:schemeClr val="accent1"/>
-          </a:effectRef>
-          <a:fontRef idx="minor">
-            <a:schemeClr val="lt1"/>
-          </a:fontRef>
-        </p:style>
-        <p:txBody>
-          <a:bodyPr rtlCol="0" anchor="ctr"/>
-          <a:lstStyle/>
-          <a:p>
-            <a:pPr algn="ctr">
               <a:defRPr sz="2200" b="1">
                 <a:solidFill>
                   <a:srgbClr val="38BDF8"/>
@@ -4649,805 +3458,35 @@
               </a:defRPr>
             </a:pPr>
             <a:r>
-              <a:t>98</a:t>
-            </a:r>
-          </a:p>
-          <a:p>
-            <a:pPr>
-              <a:defRPr sz="1000">
-                <a:solidFill>
-                  <a:srgbClr val="94A3B8"/>
-                </a:solidFill>
-              </a:defRPr>
-            </a:pPr>
-            <a:r>
-              <a:t>TOTAL STORE VISITS</a:t>
-            </a:r>
-          </a:p>
-        </p:txBody>
-      </p:sp>
-      <p:sp>
-        <p:nvSpPr>
-          <p:cNvPr id="5" name="Rounded Rectangle 4"/>
-          <p:cNvSpPr/>
+              <a:t>Module C: Executive Retail Intelligence Telemetry Dashboard</a:t>
+            </a:r>
+          </a:p>
+        </p:txBody>
+      </p:sp>
+      <p:pic>
+        <p:nvPicPr>
+          <p:cNvPr id="3" name="Picture 2" descr="executive_dashboard.png"/>
+          <p:cNvPicPr>
+            <a:picLocks noChangeAspect="1"/>
+          </p:cNvPicPr>
           <p:nvPr/>
-        </p:nvSpPr>
+        </p:nvPicPr>
+        <p:blipFill>
+          <a:blip r:embed="rId2"/>
+          <a:stretch>
+            <a:fillRect/>
+          </a:stretch>
+        </p:blipFill>
         <p:spPr>
           <a:xfrm>
-            <a:off x="3429000" y="1645920"/>
-            <a:ext cx="2468880" cy="1097280"/>
-          </a:xfrm>
-          <a:prstGeom prst="roundRect">
-            <a:avLst/>
-          </a:prstGeom>
-          <a:solidFill>
-            <a:srgbClr val="1E293B"/>
-          </a:solidFill>
-          <a:ln>
-            <a:solidFill>
-              <a:srgbClr val="C084FC"/>
-            </a:solidFill>
-          </a:ln>
-        </p:spPr>
-        <p:style>
-          <a:lnRef idx="1">
-            <a:schemeClr val="accent1"/>
-          </a:lnRef>
-          <a:fillRef idx="3">
-            <a:schemeClr val="accent1"/>
-          </a:fillRef>
-          <a:effectRef idx="2">
-            <a:schemeClr val="accent1"/>
-          </a:effectRef>
-          <a:fontRef idx="minor">
-            <a:schemeClr val="lt1"/>
-          </a:fontRef>
-        </p:style>
-        <p:txBody>
-          <a:bodyPr rtlCol="0" anchor="ctr"/>
-          <a:lstStyle/>
-          <a:p>
-            <a:pPr algn="ctr">
-              <a:defRPr sz="2200" b="1">
-                <a:solidFill>
-                  <a:srgbClr val="C084FC"/>
-                </a:solidFill>
-              </a:defRPr>
-            </a:pPr>
-            <a:r>
-              <a:t>5</a:t>
-            </a:r>
-          </a:p>
-          <a:p>
-            <a:pPr>
-              <a:defRPr sz="1000">
-                <a:solidFill>
-                  <a:srgbClr val="94A3B8"/>
-                </a:solidFill>
-              </a:defRPr>
-            </a:pPr>
-            <a:r>
-              <a:t>REGISTERED CUSTOMERS</a:t>
-            </a:r>
-          </a:p>
-        </p:txBody>
-      </p:sp>
-      <p:sp>
-        <p:nvSpPr>
-          <p:cNvPr id="6" name="Rounded Rectangle 5"/>
-          <p:cNvSpPr/>
-          <p:nvPr/>
-        </p:nvSpPr>
-        <p:spPr>
-          <a:xfrm>
-            <a:off x="6126480" y="1645920"/>
-            <a:ext cx="2468880" cy="1097280"/>
-          </a:xfrm>
-          <a:prstGeom prst="roundRect">
-            <a:avLst/>
-          </a:prstGeom>
-          <a:solidFill>
-            <a:srgbClr val="1E293B"/>
-          </a:solidFill>
-          <a:ln>
-            <a:solidFill>
-              <a:srgbClr val="34D399"/>
-            </a:solidFill>
-          </a:ln>
-        </p:spPr>
-        <p:style>
-          <a:lnRef idx="1">
-            <a:schemeClr val="accent1"/>
-          </a:lnRef>
-          <a:fillRef idx="3">
-            <a:schemeClr val="accent1"/>
-          </a:fillRef>
-          <a:effectRef idx="2">
-            <a:schemeClr val="accent1"/>
-          </a:effectRef>
-          <a:fontRef idx="minor">
-            <a:schemeClr val="lt1"/>
-          </a:fontRef>
-        </p:style>
-        <p:txBody>
-          <a:bodyPr rtlCol="0" anchor="ctr"/>
-          <a:lstStyle/>
-          <a:p>
-            <a:pPr algn="ctr">
-              <a:defRPr sz="2200" b="1">
-                <a:solidFill>
-                  <a:srgbClr val="34D399"/>
-                </a:solidFill>
-              </a:defRPr>
-            </a:pPr>
-            <a:r>
-              <a:t>45</a:t>
-            </a:r>
-          </a:p>
-          <a:p>
-            <a:pPr>
-              <a:defRPr sz="1000">
-                <a:solidFill>
-                  <a:srgbClr val="94A3B8"/>
-                </a:solidFill>
-              </a:defRPr>
-            </a:pPr>
-            <a:r>
-              <a:t>CHATBOT QUERIES</a:t>
-            </a:r>
-          </a:p>
-        </p:txBody>
-      </p:sp>
-      <p:sp>
-        <p:nvSpPr>
-          <p:cNvPr id="7" name="Rounded Rectangle 6"/>
-          <p:cNvSpPr/>
-          <p:nvPr/>
-        </p:nvSpPr>
-        <p:spPr>
-          <a:xfrm>
-            <a:off x="8823960" y="1645920"/>
-            <a:ext cx="2468880" cy="1097280"/>
-          </a:xfrm>
-          <a:prstGeom prst="roundRect">
-            <a:avLst/>
-          </a:prstGeom>
-          <a:solidFill>
-            <a:srgbClr val="1E293B"/>
-          </a:solidFill>
-          <a:ln>
-            <a:solidFill>
-              <a:srgbClr val="38BDF8"/>
-            </a:solidFill>
-          </a:ln>
-        </p:spPr>
-        <p:style>
-          <a:lnRef idx="1">
-            <a:schemeClr val="accent1"/>
-          </a:lnRef>
-          <a:fillRef idx="3">
-            <a:schemeClr val="accent1"/>
-          </a:fillRef>
-          <a:effectRef idx="2">
-            <a:schemeClr val="accent1"/>
-          </a:effectRef>
-          <a:fontRef idx="minor">
-            <a:schemeClr val="lt1"/>
-          </a:fontRef>
-        </p:style>
-        <p:txBody>
-          <a:bodyPr rtlCol="0" anchor="ctr"/>
-          <a:lstStyle/>
-          <a:p>
-            <a:pPr algn="ctr">
-              <a:defRPr sz="2200" b="1">
-                <a:solidFill>
-                  <a:srgbClr val="38BDF8"/>
-                </a:solidFill>
-              </a:defRPr>
-            </a:pPr>
-            <a:r>
-              <a:t>HEALTHY</a:t>
-            </a:r>
-          </a:p>
-          <a:p>
-            <a:pPr>
-              <a:defRPr sz="1000">
-                <a:solidFill>
-                  <a:srgbClr val="94A3B8"/>
-                </a:solidFill>
-              </a:defRPr>
-            </a:pPr>
-            <a:r>
-              <a:t>PIPELINE STATUS</a:t>
-            </a:r>
-          </a:p>
-        </p:txBody>
-      </p:sp>
-      <p:sp>
-        <p:nvSpPr>
-          <p:cNvPr id="8" name="Rounded Rectangle 7"/>
-          <p:cNvSpPr/>
-          <p:nvPr/>
-        </p:nvSpPr>
-        <p:spPr>
-          <a:xfrm>
-            <a:off x="731520" y="3017520"/>
-            <a:ext cx="5120640" cy="3108960"/>
-          </a:xfrm>
-          <a:prstGeom prst="roundRect">
-            <a:avLst/>
-          </a:prstGeom>
-          <a:solidFill>
-            <a:srgbClr val="1E293B"/>
-          </a:solidFill>
-          <a:ln>
-            <a:solidFill>
-              <a:srgbClr val="C084FC"/>
-            </a:solidFill>
-          </a:ln>
-        </p:spPr>
-        <p:style>
-          <a:lnRef idx="1">
-            <a:schemeClr val="accent1"/>
-          </a:lnRef>
-          <a:fillRef idx="3">
-            <a:schemeClr val="accent1"/>
-          </a:fillRef>
-          <a:effectRef idx="2">
-            <a:schemeClr val="accent1"/>
-          </a:effectRef>
-          <a:fontRef idx="minor">
-            <a:schemeClr val="lt1"/>
-          </a:fontRef>
-        </p:style>
-        <p:txBody>
-          <a:bodyPr rtlCol="0" anchor="ctr" wrap="square"/>
-          <a:lstStyle/>
-          <a:p>
-            <a:pPr algn="ctr">
-              <a:defRPr sz="1600" b="1">
-                <a:solidFill>
-                  <a:srgbClr val="C084FC"/>
-                </a:solidFill>
-              </a:defRPr>
-            </a:pPr>
-            <a:r>
-              <a:t>📊 Customer Sentiment Distribution</a:t>
-            </a:r>
-          </a:p>
-          <a:p>
-            <a:pPr>
-              <a:defRPr sz="1300">
-                <a:solidFill>
-                  <a:srgbClr val="F8FAFC"/>
-                </a:solidFill>
-              </a:defRPr>
-            </a:pPr>
-            <a:r>
-              <a:t>• Positive Reviews: 38 (76.0%)</a:t>
-            </a:r>
-            <a:br/>
-            <a:r>
-              <a:t>• Neutral Reviews: 8 (16.0%)</a:t>
-            </a:r>
-            <a:br/>
-            <a:r>
-              <a:t>• Negative Reviews: 4 (8.0%)</a:t>
-            </a:r>
-          </a:p>
-        </p:txBody>
-      </p:sp>
-      <p:sp>
-        <p:nvSpPr>
-          <p:cNvPr id="9" name="Rounded Rectangle 8"/>
-          <p:cNvSpPr/>
-          <p:nvPr/>
-        </p:nvSpPr>
-        <p:spPr>
-          <a:xfrm>
-            <a:off x="6217920" y="3017520"/>
-            <a:ext cx="5212080" cy="3108960"/>
-          </a:xfrm>
-          <a:prstGeom prst="roundRect">
-            <a:avLst/>
-          </a:prstGeom>
-          <a:solidFill>
-            <a:srgbClr val="1E293B"/>
-          </a:solidFill>
-          <a:ln>
-            <a:solidFill>
-              <a:srgbClr val="34D399"/>
-            </a:solidFill>
-          </a:ln>
-        </p:spPr>
-        <p:style>
-          <a:lnRef idx="1">
-            <a:schemeClr val="accent1"/>
-          </a:lnRef>
-          <a:fillRef idx="3">
-            <a:schemeClr val="accent1"/>
-          </a:fillRef>
-          <a:effectRef idx="2">
-            <a:schemeClr val="accent1"/>
-          </a:effectRef>
-          <a:fontRef idx="minor">
-            <a:schemeClr val="lt1"/>
-          </a:fontRef>
-        </p:style>
-        <p:txBody>
-          <a:bodyPr rtlCol="0" anchor="ctr" wrap="square"/>
-          <a:lstStyle/>
-          <a:p>
-            <a:pPr algn="ctr">
-              <a:defRPr sz="1600" b="1">
-                <a:solidFill>
-                  <a:srgbClr val="34D399"/>
-                </a:solidFill>
-              </a:defRPr>
-            </a:pPr>
-            <a:r>
-              <a:t>🔝 Top Chatbot FAQ Inquiries</a:t>
-            </a:r>
-          </a:p>
-          <a:p>
-            <a:pPr>
-              <a:defRPr sz="1300">
-                <a:solidFill>
-                  <a:srgbClr val="F8FAFC"/>
-                </a:solidFill>
-              </a:defRPr>
-            </a:pPr>
-            <a:r>
-              <a:t>1. order_status — 21 queries</a:t>
-            </a:r>
-          </a:p>
-          <a:p>
-            <a:pPr>
-              <a:defRPr sz="1300">
-                <a:solidFill>
-                  <a:srgbClr val="F8FAFC"/>
-                </a:solidFill>
-              </a:defRPr>
-            </a:pPr>
-            <a:r>
-              <a:t>2. return_policy — 12 queries</a:t>
-            </a:r>
-          </a:p>
-          <a:p>
-            <a:pPr>
-              <a:defRPr sz="1300">
-                <a:solidFill>
-                  <a:srgbClr val="F8FAFC"/>
-                </a:solidFill>
-              </a:defRPr>
-            </a:pPr>
-            <a:r>
-              <a:t>3. store_hours — 9 queries</a:t>
-            </a:r>
-          </a:p>
-          <a:p>
-            <a:pPr>
-              <a:defRPr sz="1300">
-                <a:solidFill>
-                  <a:srgbClr val="F8FAFC"/>
-                </a:solidFill>
-              </a:defRPr>
-            </a:pPr>
-            <a:r>
-              <a:t>4. shipping_costs — 7 queries</a:t>
-            </a:r>
-          </a:p>
-          <a:p>
-            <a:pPr>
-              <a:defRPr sz="1300">
-                <a:solidFill>
-                  <a:srgbClr val="F8FAFC"/>
-                </a:solidFill>
-              </a:defRPr>
-            </a:pPr>
-            <a:r>
-              <a:t>5. payment_methods — 5 queries</a:t>
-            </a:r>
-          </a:p>
-        </p:txBody>
-      </p:sp>
-    </p:spTree>
-  </p:cSld>
-  <p:clrMapOvr>
-    <a:masterClrMapping/>
-  </p:clrMapOvr>
-</p:sld>
-</file>
-
-<file path=ppt/slides/slide7.xml><?xml version="1.0" encoding="utf-8"?>
-<p:sld xmlns:a="http://schemas.openxmlformats.org/drawingml/2006/main" xmlns:p="http://schemas.openxmlformats.org/presentationml/2006/main" xmlns:r="http://schemas.openxmlformats.org/officeDocument/2006/relationships">
-  <p:cSld>
-    <p:bg>
-      <p:bgPr>
-        <a:solidFill>
-          <a:srgbClr val="0F172A"/>
-        </a:solidFill>
-        <a:effectLst/>
-      </p:bgPr>
-    </p:bg>
-    <p:spTree>
-      <p:nvGrpSpPr>
-        <p:cNvPr id="1" name=""/>
-        <p:cNvGrpSpPr/>
-        <p:nvPr/>
-      </p:nvGrpSpPr>
-      <p:grpSpPr/>
-      <p:sp>
-        <p:nvSpPr>
-          <p:cNvPr id="2" name="TextBox 1"/>
-          <p:cNvSpPr txBox="1"/>
-          <p:nvPr/>
-        </p:nvSpPr>
-        <p:spPr>
-          <a:xfrm>
-            <a:off x="731520" y="365760"/>
-            <a:ext cx="10698480" cy="365760"/>
+            <a:off x="548640" y="1097280"/>
+            <a:ext cx="11091672" cy="5303520"/>
           </a:xfrm>
           <a:prstGeom prst="rect">
             <a:avLst/>
           </a:prstGeom>
-          <a:noFill/>
         </p:spPr>
-        <p:txBody>
-          <a:bodyPr wrap="none">
-            <a:spAutoFit/>
-          </a:bodyPr>
-          <a:lstStyle/>
-          <a:p>
-            <a:pPr>
-              <a:defRPr sz="1100" b="1">
-                <a:solidFill>
-                  <a:srgbClr val="38BDF8"/>
-                </a:solidFill>
-              </a:defRPr>
-            </a:pPr>
-            <a:r>
-              <a:t>LIVE DEMO CAPSTONE PRESENTATION</a:t>
-            </a:r>
-          </a:p>
-        </p:txBody>
-      </p:sp>
-      <p:sp>
-        <p:nvSpPr>
-          <p:cNvPr id="3" name="TextBox 2"/>
-          <p:cNvSpPr txBox="1"/>
-          <p:nvPr/>
-        </p:nvSpPr>
-        <p:spPr>
-          <a:xfrm>
-            <a:off x="731520" y="640080"/>
-            <a:ext cx="10698480" cy="731520"/>
-          </a:xfrm>
-          <a:prstGeom prst="rect">
-            <a:avLst/>
-          </a:prstGeom>
-          <a:noFill/>
-        </p:spPr>
-        <p:txBody>
-          <a:bodyPr wrap="none">
-            <a:spAutoFit/>
-          </a:bodyPr>
-          <a:lstStyle/>
-          <a:p>
-            <a:pPr>
-              <a:defRPr sz="2600" b="1">
-                <a:solidFill>
-                  <a:srgbClr val="F8FAFC"/>
-                </a:solidFill>
-              </a:defRPr>
-            </a:pPr>
-            <a:r>
-              <a:t>Ethics, Data Privacy &amp; Bias in Retail Facial Recognition</a:t>
-            </a:r>
-          </a:p>
-        </p:txBody>
-      </p:sp>
-      <p:sp>
-        <p:nvSpPr>
-          <p:cNvPr id="4" name="Rounded Rectangle 3"/>
-          <p:cNvSpPr/>
-          <p:nvPr/>
-        </p:nvSpPr>
-        <p:spPr>
-          <a:xfrm>
-            <a:off x="731520" y="1645920"/>
-            <a:ext cx="10698480" cy="4389120"/>
-          </a:xfrm>
-          <a:prstGeom prst="roundRect">
-            <a:avLst/>
-          </a:prstGeom>
-          <a:solidFill>
-            <a:srgbClr val="1E293B"/>
-          </a:solidFill>
-          <a:ln>
-            <a:solidFill>
-              <a:srgbClr val="C084FC"/>
-            </a:solidFill>
-          </a:ln>
-        </p:spPr>
-        <p:style>
-          <a:lnRef idx="1">
-            <a:schemeClr val="accent1"/>
-          </a:lnRef>
-          <a:fillRef idx="3">
-            <a:schemeClr val="accent1"/>
-          </a:fillRef>
-          <a:effectRef idx="2">
-            <a:schemeClr val="accent1"/>
-          </a:effectRef>
-          <a:fontRef idx="minor">
-            <a:schemeClr val="lt1"/>
-          </a:fontRef>
-        </p:style>
-        <p:txBody>
-          <a:bodyPr rtlCol="0" anchor="ctr" wrap="square"/>
-          <a:lstStyle/>
-          <a:p>
-            <a:pPr algn="ctr">
-              <a:defRPr sz="2000" b="1">
-                <a:solidFill>
-                  <a:srgbClr val="C084FC"/>
-                </a:solidFill>
-              </a:defRPr>
-            </a:pPr>
-            <a:r>
-              <a:t>🛡️ Ethical Framework &amp; Compliance Protocols</a:t>
-            </a:r>
-          </a:p>
-          <a:p>
-            <a:pPr>
-              <a:defRPr sz="1300">
-                <a:solidFill>
-                  <a:srgbClr val="F8FAFC"/>
-                </a:solidFill>
-              </a:defRPr>
-            </a:pPr>
-            <a:r>
-              <a:t>• 100% Explicit Opt-In: Facial check-in operates on an explicit opt-in basis. Unregistered visitors remain anonymous guests (GUEST_3682).</a:t>
-            </a:r>
-          </a:p>
-          <a:p>
-            <a:pPr>
-              <a:defRPr sz="1300">
-                <a:solidFill>
-                  <a:srgbClr val="F8FAFC"/>
-                </a:solidFill>
-              </a:defRPr>
-            </a:pPr>
-            <a:r>
-              <a:t>• Zero Raw Image Storage: Raw photos discarded immediately after feature extraction — ONLY 128D mathematical hash vectors stored in face_db.pkl.</a:t>
-            </a:r>
-          </a:p>
-          <a:p>
-            <a:pPr>
-              <a:defRPr sz="1300">
-                <a:solidFill>
-                  <a:srgbClr val="F8FAFC"/>
-                </a:solidFill>
-              </a:defRPr>
-            </a:pPr>
-            <a:r>
-              <a:t>• GDPR &amp; CCPA Adherence: Complies with GDPR Article 9 &amp; CCPA biometric provisions with full right-to-be-forgotten deletion support.</a:t>
-            </a:r>
-          </a:p>
-          <a:p>
-            <a:pPr>
-              <a:defRPr sz="1300">
-                <a:solidFill>
-                  <a:srgbClr val="F8FAFC"/>
-                </a:solidFill>
-              </a:defRPr>
-            </a:pPr>
-            <a:r>
-              <a:t>• Demographic Bias Mitigation: Distance thresholding (0.85) &amp; fallback guest routes minimize false acceptance rates across diverse demographics.</a:t>
-            </a:r>
-          </a:p>
-        </p:txBody>
-      </p:sp>
-    </p:spTree>
-  </p:cSld>
-  <p:clrMapOvr>
-    <a:masterClrMapping/>
-  </p:clrMapOvr>
-</p:sld>
-</file>
-
-<file path=ppt/slides/slide8.xml><?xml version="1.0" encoding="utf-8"?>
-<p:sld xmlns:a="http://schemas.openxmlformats.org/drawingml/2006/main" xmlns:p="http://schemas.openxmlformats.org/presentationml/2006/main" xmlns:r="http://schemas.openxmlformats.org/officeDocument/2006/relationships">
-  <p:cSld>
-    <p:bg>
-      <p:bgPr>
-        <a:solidFill>
-          <a:srgbClr val="0F172A"/>
-        </a:solidFill>
-        <a:effectLst/>
-      </p:bgPr>
-    </p:bg>
-    <p:spTree>
-      <p:nvGrpSpPr>
-        <p:cNvPr id="1" name=""/>
-        <p:cNvGrpSpPr/>
-        <p:nvPr/>
-      </p:nvGrpSpPr>
-      <p:grpSpPr/>
-      <p:sp>
-        <p:nvSpPr>
-          <p:cNvPr id="2" name="TextBox 1"/>
-          <p:cNvSpPr txBox="1"/>
-          <p:nvPr/>
-        </p:nvSpPr>
-        <p:spPr>
-          <a:xfrm>
-            <a:off x="731520" y="365760"/>
-            <a:ext cx="10698480" cy="365760"/>
-          </a:xfrm>
-          <a:prstGeom prst="rect">
-            <a:avLst/>
-          </a:prstGeom>
-          <a:noFill/>
-        </p:spPr>
-        <p:txBody>
-          <a:bodyPr wrap="none">
-            <a:spAutoFit/>
-          </a:bodyPr>
-          <a:lstStyle/>
-          <a:p>
-            <a:pPr>
-              <a:defRPr sz="1100" b="1">
-                <a:solidFill>
-                  <a:srgbClr val="38BDF8"/>
-                </a:solidFill>
-              </a:defRPr>
-            </a:pPr>
-            <a:r>
-              <a:t>LIVE DEMO CAPSTONE PRESENTATION</a:t>
-            </a:r>
-          </a:p>
-        </p:txBody>
-      </p:sp>
-      <p:sp>
-        <p:nvSpPr>
-          <p:cNvPr id="3" name="TextBox 2"/>
-          <p:cNvSpPr txBox="1"/>
-          <p:nvPr/>
-        </p:nvSpPr>
-        <p:spPr>
-          <a:xfrm>
-            <a:off x="731520" y="640080"/>
-            <a:ext cx="10698480" cy="731520"/>
-          </a:xfrm>
-          <a:prstGeom prst="rect">
-            <a:avLst/>
-          </a:prstGeom>
-          <a:noFill/>
-        </p:spPr>
-        <p:txBody>
-          <a:bodyPr wrap="none">
-            <a:spAutoFit/>
-          </a:bodyPr>
-          <a:lstStyle/>
-          <a:p>
-            <a:pPr>
-              <a:defRPr sz="2600" b="1">
-                <a:solidFill>
-                  <a:srgbClr val="F8FAFC"/>
-                </a:solidFill>
-              </a:defRPr>
-            </a:pPr>
-            <a:r>
-              <a:t>Conclusion &amp; Project Deliverables</a:t>
-            </a:r>
-          </a:p>
-        </p:txBody>
-      </p:sp>
-      <p:sp>
-        <p:nvSpPr>
-          <p:cNvPr id="4" name="Rounded Rectangle 3"/>
-          <p:cNvSpPr/>
-          <p:nvPr/>
-        </p:nvSpPr>
-        <p:spPr>
-          <a:xfrm>
-            <a:off x="731520" y="1645920"/>
-            <a:ext cx="10698480" cy="4389120"/>
-          </a:xfrm>
-          <a:prstGeom prst="roundRect">
-            <a:avLst/>
-          </a:prstGeom>
-          <a:solidFill>
-            <a:srgbClr val="1E293B"/>
-          </a:solidFill>
-          <a:ln>
-            <a:solidFill>
-              <a:srgbClr val="34D399"/>
-            </a:solidFill>
-          </a:ln>
-        </p:spPr>
-        <p:style>
-          <a:lnRef idx="1">
-            <a:schemeClr val="accent1"/>
-          </a:lnRef>
-          <a:fillRef idx="3">
-            <a:schemeClr val="accent1"/>
-          </a:fillRef>
-          <a:effectRef idx="2">
-            <a:schemeClr val="accent1"/>
-          </a:effectRef>
-          <a:fontRef idx="minor">
-            <a:schemeClr val="lt1"/>
-          </a:fontRef>
-        </p:style>
-        <p:txBody>
-          <a:bodyPr rtlCol="0" anchor="ctr" wrap="square"/>
-          <a:lstStyle/>
-          <a:p>
-            <a:pPr algn="ctr">
-              <a:defRPr sz="2000" b="1">
-                <a:solidFill>
-                  <a:srgbClr val="34D399"/>
-                </a:solidFill>
-              </a:defRPr>
-            </a:pPr>
-            <a:r>
-              <a:t>🎉 Final Capstone Project Summary</a:t>
-            </a:r>
-          </a:p>
-          <a:p>
-            <a:pPr>
-              <a:defRPr sz="1400">
-                <a:solidFill>
-                  <a:srgbClr val="F8FAFC"/>
-                </a:solidFill>
-              </a:defRPr>
-            </a:pPr>
-            <a:r>
-              <a:t>• 100% Automated Test Verification: 8/8 unit &amp; integration tests passing in 1.62s (run_tests.py OK).</a:t>
-            </a:r>
-          </a:p>
-          <a:p>
-            <a:pPr>
-              <a:defRPr sz="1400">
-                <a:solidFill>
-                  <a:srgbClr val="F8FAFC"/>
-                </a:solidFill>
-              </a:defRPr>
-            </a:pPr>
-            <a:r>
-              <a:t>• Full Stack Architecture: PyTorch MobileNetV2 + OpenCV + TF-IDF NLP + FastAPI Gateway + Streamlit UI.</a:t>
-            </a:r>
-          </a:p>
-          <a:p>
-            <a:pPr>
-              <a:defRPr sz="1400">
-                <a:solidFill>
-                  <a:srgbClr val="F8FAFC"/>
-                </a:solidFill>
-              </a:defRPr>
-            </a:pPr>
-            <a:r>
-              <a:t>• Production Containerization: Dockerfile + docker-compose.yml + GitHub Actions CI/CD (deploy.yml).</a:t>
-            </a:r>
-          </a:p>
-          <a:p>
-            <a:pPr>
-              <a:defRPr sz="1400">
-                <a:solidFill>
-                  <a:srgbClr val="F8FAFC"/>
-                </a:solidFill>
-              </a:defRPr>
-            </a:pPr>
-            <a:r>
-              <a:t>• Live GitHub Repository: github.com/shaurya3000/smart-retail-ai</a:t>
-            </a:r>
-          </a:p>
-        </p:txBody>
-      </p:sp>
+      </p:pic>
     </p:spTree>
   </p:cSld>
   <p:clrMapOvr>

</xml_diff>

<commit_message>
Embed high-resolution UI screenshots into PowerPoint slides and README
</commit_message>
<xml_diff>
--- a/Smart_Retail_Platform_Demo_Presentation.pptx
+++ b/Smart_Retail_Platform_Demo_Presentation.pptx
@@ -3142,7 +3142,7 @@
               </a:defRPr>
             </a:pPr>
             <a:r>
-              <a:t>Live Application Demonstration Deck with Embedded UI Screenshots</a:t>
+              <a:t>Live Application Demonstration Deck with Embedded High-Resolution UI Screenshots</a:t>
             </a:r>
           </a:p>
         </p:txBody>
@@ -3181,7 +3181,7 @@
         </p:nvSpPr>
         <p:spPr>
           <a:xfrm>
-            <a:off x="548640" y="365760"/>
+            <a:off x="548640" y="274320"/>
             <a:ext cx="10972800" cy="548640"/>
           </a:xfrm>
           <a:prstGeom prst="rect">
@@ -3224,8 +3224,8 @@
         </p:blipFill>
         <p:spPr>
           <a:xfrm>
-            <a:off x="548640" y="1097280"/>
-            <a:ext cx="11091672" cy="5303520"/>
+            <a:off x="548640" y="1005840"/>
+            <a:ext cx="11091672" cy="5486400"/>
           </a:xfrm>
           <a:prstGeom prst="rect">
             <a:avLst/>
@@ -3266,7 +3266,7 @@
         </p:nvSpPr>
         <p:spPr>
           <a:xfrm>
-            <a:off x="548640" y="365760"/>
+            <a:off x="548640" y="274320"/>
             <a:ext cx="10972800" cy="548640"/>
           </a:xfrm>
           <a:prstGeom prst="rect">
@@ -3309,8 +3309,8 @@
         </p:blipFill>
         <p:spPr>
           <a:xfrm>
-            <a:off x="548640" y="1097280"/>
-            <a:ext cx="11091672" cy="5303520"/>
+            <a:off x="548640" y="1005840"/>
+            <a:ext cx="11091672" cy="5486400"/>
           </a:xfrm>
           <a:prstGeom prst="rect">
             <a:avLst/>
@@ -3351,7 +3351,7 @@
         </p:nvSpPr>
         <p:spPr>
           <a:xfrm>
-            <a:off x="548640" y="365760"/>
+            <a:off x="548640" y="274320"/>
             <a:ext cx="10972800" cy="548640"/>
           </a:xfrm>
           <a:prstGeom prst="rect">
@@ -3394,8 +3394,8 @@
         </p:blipFill>
         <p:spPr>
           <a:xfrm>
-            <a:off x="548640" y="1097280"/>
-            <a:ext cx="11091672" cy="5303520"/>
+            <a:off x="548640" y="1005840"/>
+            <a:ext cx="11091672" cy="5486400"/>
           </a:xfrm>
           <a:prstGeom prst="rect">
             <a:avLst/>
@@ -3436,7 +3436,7 @@
         </p:nvSpPr>
         <p:spPr>
           <a:xfrm>
-            <a:off x="548640" y="365760"/>
+            <a:off x="548640" y="274320"/>
             <a:ext cx="10972800" cy="548640"/>
           </a:xfrm>
           <a:prstGeom prst="rect">
@@ -3479,8 +3479,8 @@
         </p:blipFill>
         <p:spPr>
           <a:xfrm>
-            <a:off x="548640" y="1097280"/>
-            <a:ext cx="11091672" cy="5303520"/>
+            <a:off x="548640" y="1005840"/>
+            <a:ext cx="11091672" cy="5486400"/>
           </a:xfrm>
           <a:prstGeom prst="rect">
             <a:avLst/>

</xml_diff>

<commit_message>
Update PowerPoint deck with split-layout technical explanations and live UI screenshots
</commit_message>
<xml_diff>
--- a/Smart_Retail_Platform_Demo_Presentation.pptx
+++ b/Smart_Retail_Platform_Demo_Presentation.pptx
@@ -10,6 +10,10 @@
     <p:sldId id="258" r:id="rId9"/>
     <p:sldId id="259" r:id="rId10"/>
     <p:sldId id="260" r:id="rId11"/>
+    <p:sldId id="261" r:id="rId12"/>
+    <p:sldId id="262" r:id="rId13"/>
+    <p:sldId id="263" r:id="rId14"/>
+    <p:sldId id="264" r:id="rId15"/>
   </p:sldIdLst>
   <p:sldSz cx="12191695" cy="6858000" type="screen4x3"/>
   <p:notesSz cx="6858000" cy="9144000"/>
@@ -3102,14 +3106,57 @@
       <p:grpSpPr/>
       <p:sp>
         <p:nvSpPr>
-          <p:cNvPr id="2" name="TextBox 1"/>
+          <p:cNvPr id="2" name="Rectangle 1"/>
+          <p:cNvSpPr/>
+          <p:nvPr/>
+        </p:nvSpPr>
+        <p:spPr>
+          <a:xfrm>
+            <a:off x="731520" y="1645920"/>
+            <a:ext cx="137160" cy="3474720"/>
+          </a:xfrm>
+          <a:prstGeom prst="rect">
+            <a:avLst/>
+          </a:prstGeom>
+          <a:solidFill>
+            <a:srgbClr val="38BDF8"/>
+          </a:solidFill>
+          <a:ln>
+            <a:noFill/>
+          </a:ln>
+        </p:spPr>
+        <p:style>
+          <a:lnRef idx="1">
+            <a:schemeClr val="accent1"/>
+          </a:lnRef>
+          <a:fillRef idx="3">
+            <a:schemeClr val="accent1"/>
+          </a:fillRef>
+          <a:effectRef idx="2">
+            <a:schemeClr val="accent1"/>
+          </a:effectRef>
+          <a:fontRef idx="minor">
+            <a:schemeClr val="lt1"/>
+          </a:fontRef>
+        </p:style>
+        <p:txBody>
+          <a:bodyPr rtlCol="0" anchor="ctr"/>
+          <a:lstStyle/>
+          <a:p>
+            <a:pPr algn="ctr"/>
+          </a:p>
+        </p:txBody>
+      </p:sp>
+      <p:sp>
+        <p:nvSpPr>
+          <p:cNvPr id="3" name="TextBox 2"/>
           <p:cNvSpPr txBox="1"/>
           <p:nvPr/>
         </p:nvSpPr>
         <p:spPr>
           <a:xfrm>
-            <a:off x="914400" y="2011680"/>
-            <a:ext cx="10332720" cy="1828800"/>
+            <a:off x="1097280" y="1645920"/>
+            <a:ext cx="10058400" cy="1828800"/>
           </a:xfrm>
           <a:prstGeom prst="rect">
             <a:avLst/>
@@ -3130,19 +3177,81 @@
               </a:defRPr>
             </a:pPr>
             <a:r>
-              <a:t>Smart Retail &amp; Customer Intelligence Platform</a:t>
-            </a:r>
-          </a:p>
-          <a:p>
-            <a:pPr>
-              <a:defRPr sz="1800">
+              <a:t>AI-Powered Smart Retail &amp;</a:t>
+            </a:r>
+            <a:br/>
+            <a:r>
+              <a:t>Customer Intelligence Platform</a:t>
+            </a:r>
+          </a:p>
+        </p:txBody>
+      </p:sp>
+      <p:sp>
+        <p:nvSpPr>
+          <p:cNvPr id="4" name="TextBox 3"/>
+          <p:cNvSpPr txBox="1"/>
+          <p:nvPr/>
+        </p:nvSpPr>
+        <p:spPr>
+          <a:xfrm>
+            <a:off x="1097280" y="3474720"/>
+            <a:ext cx="10058400" cy="914400"/>
+          </a:xfrm>
+          <a:prstGeom prst="rect">
+            <a:avLst/>
+          </a:prstGeom>
+          <a:noFill/>
+        </p:spPr>
+        <p:txBody>
+          <a:bodyPr wrap="none">
+            <a:spAutoFit/>
+          </a:bodyPr>
+          <a:lstStyle/>
+          <a:p>
+            <a:pPr>
+              <a:defRPr sz="1600">
                 <a:solidFill>
                   <a:srgbClr val="C084FC"/>
                 </a:solidFill>
               </a:defRPr>
             </a:pPr>
             <a:r>
-              <a:t>Live Application Demonstration Deck with Embedded High-Resolution UI Screenshots</a:t>
+              <a:t>Full Capstone Presentation: Technical Architecture, ML Implementation &amp; Live UI Walkthrough</a:t>
+            </a:r>
+          </a:p>
+        </p:txBody>
+      </p:sp>
+      <p:sp>
+        <p:nvSpPr>
+          <p:cNvPr id="5" name="TextBox 4"/>
+          <p:cNvSpPr txBox="1"/>
+          <p:nvPr/>
+        </p:nvSpPr>
+        <p:spPr>
+          <a:xfrm>
+            <a:off x="1097280" y="5029200"/>
+            <a:ext cx="10058400" cy="914400"/>
+          </a:xfrm>
+          <a:prstGeom prst="rect">
+            <a:avLst/>
+          </a:prstGeom>
+          <a:noFill/>
+        </p:spPr>
+        <p:txBody>
+          <a:bodyPr wrap="none">
+            <a:spAutoFit/>
+          </a:bodyPr>
+          <a:lstStyle/>
+          <a:p>
+            <a:pPr>
+              <a:defRPr sz="1200">
+                <a:solidFill>
+                  <a:srgbClr val="94A3B8"/>
+                </a:solidFill>
+              </a:defRPr>
+            </a:pPr>
+            <a:r>
+              <a:t>Presenter: Shaurya | Stack: OpenCV, PyTorch MobileNetV2, TF-IDF NLP, FastAPI, Streamlit, Docker | Status: 100% Tested</a:t>
             </a:r>
           </a:p>
         </p:txBody>
@@ -3182,7 +3291,7 @@
         <p:spPr>
           <a:xfrm>
             <a:off x="548640" y="274320"/>
-            <a:ext cx="10972800" cy="548640"/>
+            <a:ext cx="10972800" cy="365760"/>
           </a:xfrm>
           <a:prstGeom prst="rect">
             <a:avLst/>
@@ -3196,42 +3305,257 @@
           <a:lstStyle/>
           <a:p>
             <a:pPr>
-              <a:defRPr sz="2200" b="1">
+              <a:defRPr sz="1100" b="1">
                 <a:solidFill>
                   <a:srgbClr val="38BDF8"/>
                 </a:solidFill>
               </a:defRPr>
             </a:pPr>
             <a:r>
-              <a:t>Module A: Biometric Face Recognition &amp; Customer Visit Logger</a:t>
-            </a:r>
-          </a:p>
-        </p:txBody>
-      </p:sp>
-      <p:pic>
-        <p:nvPicPr>
-          <p:cNvPr id="3" name="Picture 2" descr="face_recognition.png"/>
-          <p:cNvPicPr>
-            <a:picLocks noChangeAspect="1"/>
-          </p:cNvPicPr>
+              <a:t>MAJOR CAPSTONE PROJECT DEMO</a:t>
+            </a:r>
+          </a:p>
+        </p:txBody>
+      </p:sp>
+      <p:sp>
+        <p:nvSpPr>
+          <p:cNvPr id="3" name="TextBox 2"/>
+          <p:cNvSpPr txBox="1"/>
           <p:nvPr/>
-        </p:nvPicPr>
-        <p:blipFill>
-          <a:blip r:embed="rId2"/>
-          <a:stretch>
-            <a:fillRect/>
-          </a:stretch>
-        </p:blipFill>
-        <p:spPr>
-          <a:xfrm>
-            <a:off x="548640" y="1005840"/>
-            <a:ext cx="11091672" cy="5486400"/>
+        </p:nvSpPr>
+        <p:spPr>
+          <a:xfrm>
+            <a:off x="548640" y="594360"/>
+            <a:ext cx="10972800" cy="640080"/>
           </a:xfrm>
           <a:prstGeom prst="rect">
             <a:avLst/>
           </a:prstGeom>
-        </p:spPr>
-      </p:pic>
+          <a:noFill/>
+        </p:spPr>
+        <p:txBody>
+          <a:bodyPr wrap="none">
+            <a:spAutoFit/>
+          </a:bodyPr>
+          <a:lstStyle/>
+          <a:p>
+            <a:pPr>
+              <a:defRPr sz="2400" b="1">
+                <a:solidFill>
+                  <a:srgbClr val="F8FAFC"/>
+                </a:solidFill>
+              </a:defRPr>
+            </a:pPr>
+            <a:r>
+              <a:t>1. Executive Overview &amp; Problem Statement</a:t>
+            </a:r>
+          </a:p>
+        </p:txBody>
+      </p:sp>
+      <p:sp>
+        <p:nvSpPr>
+          <p:cNvPr id="4" name="Rounded Rectangle 3"/>
+          <p:cNvSpPr/>
+          <p:nvPr/>
+        </p:nvSpPr>
+        <p:spPr>
+          <a:xfrm>
+            <a:off x="548640" y="1371600"/>
+            <a:ext cx="5303520" cy="4937760"/>
+          </a:xfrm>
+          <a:prstGeom prst="roundRect">
+            <a:avLst/>
+          </a:prstGeom>
+          <a:solidFill>
+            <a:srgbClr val="1E293B"/>
+          </a:solidFill>
+          <a:ln>
+            <a:solidFill>
+              <a:srgbClr val="38BDF8"/>
+            </a:solidFill>
+          </a:ln>
+        </p:spPr>
+        <p:style>
+          <a:lnRef idx="1">
+            <a:schemeClr val="accent1"/>
+          </a:lnRef>
+          <a:fillRef idx="3">
+            <a:schemeClr val="accent1"/>
+          </a:fillRef>
+          <a:effectRef idx="2">
+            <a:schemeClr val="accent1"/>
+          </a:effectRef>
+          <a:fontRef idx="minor">
+            <a:schemeClr val="lt1"/>
+          </a:fontRef>
+        </p:style>
+        <p:txBody>
+          <a:bodyPr rtlCol="0" anchor="ctr" wrap="square"/>
+          <a:lstStyle/>
+          <a:p>
+            <a:pPr algn="ctr">
+              <a:defRPr sz="1800" b="1">
+                <a:solidFill>
+                  <a:srgbClr val="38BDF8"/>
+                </a:solidFill>
+              </a:defRPr>
+            </a:pPr>
+            <a:r>
+              <a:t>❌ Retail Challenges</a:t>
+            </a:r>
+          </a:p>
+          <a:p>
+            <a:pPr>
+              <a:defRPr sz="1200">
+                <a:solidFill>
+                  <a:srgbClr val="F8FAFC"/>
+                </a:solidFill>
+              </a:defRPr>
+            </a:pPr>
+            <a:r>
+              <a:t>• In-Store Customer Friction: Inability to automatically recognize returning VIP customers or track visit frequency.</a:t>
+            </a:r>
+          </a:p>
+          <a:p>
+            <a:pPr>
+              <a:defRPr sz="1200">
+                <a:solidFill>
+                  <a:srgbClr val="F8FAFC"/>
+                </a:solidFill>
+              </a:defRPr>
+            </a:pPr>
+            <a:r>
+              <a:t>• Manual Cataloging Bottlenecks: Time-consuming sorting across 5 retail categories.</a:t>
+            </a:r>
+          </a:p>
+          <a:p>
+            <a:pPr>
+              <a:defRPr sz="1200">
+                <a:solidFill>
+                  <a:srgbClr val="F8FAFC"/>
+                </a:solidFill>
+              </a:defRPr>
+            </a:pPr>
+            <a:r>
+              <a:t>• Feedback Delays: Failure to monitor customer sentiment and review trends in real-time.</a:t>
+            </a:r>
+          </a:p>
+          <a:p>
+            <a:pPr>
+              <a:defRPr sz="1200">
+                <a:solidFill>
+                  <a:srgbClr val="F8FAFC"/>
+                </a:solidFill>
+              </a:defRPr>
+            </a:pPr>
+            <a:r>
+              <a:t>• High Support Volume: Repetitive queries (order tracking, returns) overwhelming support staff.</a:t>
+            </a:r>
+          </a:p>
+        </p:txBody>
+      </p:sp>
+      <p:sp>
+        <p:nvSpPr>
+          <p:cNvPr id="5" name="Rounded Rectangle 4"/>
+          <p:cNvSpPr/>
+          <p:nvPr/>
+        </p:nvSpPr>
+        <p:spPr>
+          <a:xfrm>
+            <a:off x="6217920" y="1371600"/>
+            <a:ext cx="5394960" cy="4937760"/>
+          </a:xfrm>
+          <a:prstGeom prst="roundRect">
+            <a:avLst/>
+          </a:prstGeom>
+          <a:solidFill>
+            <a:srgbClr val="1E293B"/>
+          </a:solidFill>
+          <a:ln>
+            <a:solidFill>
+              <a:srgbClr val="34D399"/>
+            </a:solidFill>
+          </a:ln>
+        </p:spPr>
+        <p:style>
+          <a:lnRef idx="1">
+            <a:schemeClr val="accent1"/>
+          </a:lnRef>
+          <a:fillRef idx="3">
+            <a:schemeClr val="accent1"/>
+          </a:fillRef>
+          <a:effectRef idx="2">
+            <a:schemeClr val="accent1"/>
+          </a:effectRef>
+          <a:fontRef idx="minor">
+            <a:schemeClr val="lt1"/>
+          </a:fontRef>
+        </p:style>
+        <p:txBody>
+          <a:bodyPr rtlCol="0" anchor="ctr" wrap="square"/>
+          <a:lstStyle/>
+          <a:p>
+            <a:pPr algn="ctr">
+              <a:defRPr sz="1800" b="1">
+                <a:solidFill>
+                  <a:srgbClr val="34D399"/>
+                </a:solidFill>
+              </a:defRPr>
+            </a:pPr>
+            <a:r>
+              <a:t>✅ The Smart Retail AI Solution</a:t>
+            </a:r>
+          </a:p>
+          <a:p>
+            <a:pPr>
+              <a:defRPr sz="1200">
+                <a:solidFill>
+                  <a:srgbClr val="F8FAFC"/>
+                </a:solidFill>
+              </a:defRPr>
+            </a:pPr>
+            <a:r>
+              <a:t>• Biometric Customer Recognition: 128D facial feature encodings &amp; automatic visit logging with VIP tier detection.</a:t>
+            </a:r>
+          </a:p>
+          <a:p>
+            <a:pPr>
+              <a:defRPr sz="1200">
+                <a:solidFill>
+                  <a:srgbClr val="F8FAFC"/>
+                </a:solidFill>
+              </a:defRPr>
+            </a:pPr>
+            <a:r>
+              <a:t>• MobileNetV2 Product Classifier: PyTorch Deep Transfer Learning for 5 retail categories with 95%+ confidence.</a:t>
+            </a:r>
+          </a:p>
+          <a:p>
+            <a:pPr>
+              <a:defRPr sz="1200">
+                <a:solidFill>
+                  <a:srgbClr val="F8FAFC"/>
+                </a:solidFill>
+              </a:defRPr>
+            </a:pPr>
+            <a:r>
+              <a:t>• Calibrated Sentiment Engine: TF-IDF + Logistic Regression NLP pipeline for review classification.</a:t>
+            </a:r>
+          </a:p>
+          <a:p>
+            <a:pPr>
+              <a:defRPr sz="1200">
+                <a:solidFill>
+                  <a:srgbClr val="F8FAFC"/>
+                </a:solidFill>
+              </a:defRPr>
+            </a:pPr>
+            <a:r>
+              <a:t>• Hybrid FAQ Chatbot: High-precision rule matching + ML intent fallback for 24/7 support.</a:t>
+            </a:r>
+          </a:p>
+        </p:txBody>
+      </p:sp>
     </p:spTree>
   </p:cSld>
   <p:clrMapOvr>
@@ -3267,7 +3591,7 @@
         <p:spPr>
           <a:xfrm>
             <a:off x="548640" y="274320"/>
-            <a:ext cx="10972800" cy="548640"/>
+            <a:ext cx="10972800" cy="365760"/>
           </a:xfrm>
           <a:prstGeom prst="rect">
             <a:avLst/>
@@ -3281,21 +3605,170 @@
           <a:lstStyle/>
           <a:p>
             <a:pPr>
-              <a:defRPr sz="2200" b="1">
+              <a:defRPr sz="1100" b="1">
                 <a:solidFill>
                   <a:srgbClr val="38BDF8"/>
                 </a:solidFill>
               </a:defRPr>
             </a:pPr>
             <a:r>
-              <a:t>Module B: Customer Feedback Sentiment Analysis NLP Engine</a:t>
+              <a:t>MAJOR CAPSTONE PROJECT DEMO</a:t>
+            </a:r>
+          </a:p>
+        </p:txBody>
+      </p:sp>
+      <p:sp>
+        <p:nvSpPr>
+          <p:cNvPr id="3" name="TextBox 2"/>
+          <p:cNvSpPr txBox="1"/>
+          <p:nvPr/>
+        </p:nvSpPr>
+        <p:spPr>
+          <a:xfrm>
+            <a:off x="548640" y="594360"/>
+            <a:ext cx="10972800" cy="640080"/>
+          </a:xfrm>
+          <a:prstGeom prst="rect">
+            <a:avLst/>
+          </a:prstGeom>
+          <a:noFill/>
+        </p:spPr>
+        <p:txBody>
+          <a:bodyPr wrap="none">
+            <a:spAutoFit/>
+          </a:bodyPr>
+          <a:lstStyle/>
+          <a:p>
+            <a:pPr>
+              <a:defRPr sz="2400" b="1">
+                <a:solidFill>
+                  <a:srgbClr val="F8FAFC"/>
+                </a:solidFill>
+              </a:defRPr>
+            </a:pPr>
+            <a:r>
+              <a:t>2. Module A: Face Recognition &amp; VIP Customer Logger</a:t>
+            </a:r>
+          </a:p>
+        </p:txBody>
+      </p:sp>
+      <p:sp>
+        <p:nvSpPr>
+          <p:cNvPr id="4" name="Rounded Rectangle 3"/>
+          <p:cNvSpPr/>
+          <p:nvPr/>
+        </p:nvSpPr>
+        <p:spPr>
+          <a:xfrm>
+            <a:off x="548640" y="1371600"/>
+            <a:ext cx="5120640" cy="4937760"/>
+          </a:xfrm>
+          <a:prstGeom prst="roundRect">
+            <a:avLst/>
+          </a:prstGeom>
+          <a:solidFill>
+            <a:srgbClr val="1E293B"/>
+          </a:solidFill>
+          <a:ln>
+            <a:solidFill>
+              <a:srgbClr val="C084FC"/>
+            </a:solidFill>
+          </a:ln>
+        </p:spPr>
+        <p:style>
+          <a:lnRef idx="1">
+            <a:schemeClr val="accent1"/>
+          </a:lnRef>
+          <a:fillRef idx="3">
+            <a:schemeClr val="accent1"/>
+          </a:fillRef>
+          <a:effectRef idx="2">
+            <a:schemeClr val="accent1"/>
+          </a:effectRef>
+          <a:fontRef idx="minor">
+            <a:schemeClr val="lt1"/>
+          </a:fontRef>
+        </p:style>
+        <p:txBody>
+          <a:bodyPr rtlCol="0" anchor="ctr" wrap="square"/>
+          <a:lstStyle/>
+          <a:p>
+            <a:pPr algn="ctr">
+              <a:defRPr sz="1700" b="1">
+                <a:solidFill>
+                  <a:srgbClr val="C084FC"/>
+                </a:solidFill>
+              </a:defRPr>
+            </a:pPr>
+            <a:r>
+              <a:t>⚙️ Technical Implementation</a:t>
+            </a:r>
+          </a:p>
+          <a:p>
+            <a:pPr>
+              <a:defRPr sz="1100">
+                <a:solidFill>
+                  <a:srgbClr val="F8FAFC"/>
+                </a:solidFill>
+              </a:defRPr>
+            </a:pPr>
+            <a:r>
+              <a:t>• Algorithm: OpenCV frame detection + 128D HOG gradient facial landmark feature encodings.</a:t>
+            </a:r>
+          </a:p>
+          <a:p>
+            <a:pPr>
+              <a:defRPr sz="1100">
+                <a:solidFill>
+                  <a:srgbClr val="F8FAFC"/>
+                </a:solidFill>
+              </a:defRPr>
+            </a:pPr>
+            <a:r>
+              <a:t>• Distance Metric: Cosine similarity matching against registered database encodings in face_db.pkl (Threshold = 0.85).</a:t>
+            </a:r>
+          </a:p>
+          <a:p>
+            <a:pPr>
+              <a:defRPr sz="1100">
+                <a:solidFill>
+                  <a:srgbClr val="F8FAFC"/>
+                </a:solidFill>
+              </a:defRPr>
+            </a:pPr>
+            <a:r>
+              <a:t>• Persistent Telemetry: Automatically updates customer visit logs (customer_visits.json) with timestamps and VIP loyalty tiers.</a:t>
+            </a:r>
+          </a:p>
+          <a:p>
+            <a:pPr>
+              <a:defRPr sz="1100">
+                <a:solidFill>
+                  <a:srgbClr val="F8FAFC"/>
+                </a:solidFill>
+              </a:defRPr>
+            </a:pPr>
+            <a:r>
+              <a:t>• Privacy &amp; Consent: 100% Opt-In consent. Raw images are discarded immediately — ONLY 128D mathematical hash vectors are stored.</a:t>
+            </a:r>
+          </a:p>
+          <a:p>
+            <a:pPr>
+              <a:defRPr sz="1100">
+                <a:solidFill>
+                  <a:srgbClr val="F8FAFC"/>
+                </a:solidFill>
+              </a:defRPr>
+            </a:pPr>
+            <a:r>
+              <a:t>• Live Demo Result: Recognized Bob Johnson (Platinum VIP, 37 visits, 70.0% confidence).</a:t>
             </a:r>
           </a:p>
         </p:txBody>
       </p:sp>
       <p:pic>
         <p:nvPicPr>
-          <p:cNvPr id="3" name="Picture 2" descr="sentiment_analysis_2.png"/>
+          <p:cNvPr id="5" name="Picture 4" descr="face_recognition.png"/>
           <p:cNvPicPr>
             <a:picLocks noChangeAspect="1"/>
           </p:cNvPicPr>
@@ -3309,8 +3782,8 @@
         </p:blipFill>
         <p:spPr>
           <a:xfrm>
-            <a:off x="548640" y="1005840"/>
-            <a:ext cx="11091672" cy="5486400"/>
+            <a:off x="5943600" y="1371600"/>
+            <a:ext cx="5669280" cy="4937760"/>
           </a:xfrm>
           <a:prstGeom prst="rect">
             <a:avLst/>
@@ -3352,7 +3825,7 @@
         <p:spPr>
           <a:xfrm>
             <a:off x="548640" y="274320"/>
-            <a:ext cx="10972800" cy="548640"/>
+            <a:ext cx="10972800" cy="365760"/>
           </a:xfrm>
           <a:prstGeom prst="rect">
             <a:avLst/>
@@ -3366,42 +3839,281 @@
           <a:lstStyle/>
           <a:p>
             <a:pPr>
-              <a:defRPr sz="2200" b="1">
+              <a:defRPr sz="1100" b="1">
                 <a:solidFill>
                   <a:srgbClr val="38BDF8"/>
                 </a:solidFill>
               </a:defRPr>
             </a:pPr>
             <a:r>
-              <a:t>Module B: AI Retail Customer Support Assistant</a:t>
-            </a:r>
-          </a:p>
-        </p:txBody>
-      </p:sp>
-      <p:pic>
-        <p:nvPicPr>
-          <p:cNvPr id="3" name="Picture 2" descr="chatbot_assistant.png"/>
-          <p:cNvPicPr>
-            <a:picLocks noChangeAspect="1"/>
-          </p:cNvPicPr>
+              <a:t>MAJOR CAPSTONE PROJECT DEMO</a:t>
+            </a:r>
+          </a:p>
+        </p:txBody>
+      </p:sp>
+      <p:sp>
+        <p:nvSpPr>
+          <p:cNvPr id="3" name="TextBox 2"/>
+          <p:cNvSpPr txBox="1"/>
           <p:nvPr/>
-        </p:nvPicPr>
-        <p:blipFill>
-          <a:blip r:embed="rId2"/>
-          <a:stretch>
-            <a:fillRect/>
-          </a:stretch>
-        </p:blipFill>
-        <p:spPr>
-          <a:xfrm>
-            <a:off x="548640" y="1005840"/>
-            <a:ext cx="11091672" cy="5486400"/>
+        </p:nvSpPr>
+        <p:spPr>
+          <a:xfrm>
+            <a:off x="548640" y="594360"/>
+            <a:ext cx="10972800" cy="640080"/>
           </a:xfrm>
           <a:prstGeom prst="rect">
             <a:avLst/>
           </a:prstGeom>
-        </p:spPr>
-      </p:pic>
+          <a:noFill/>
+        </p:spPr>
+        <p:txBody>
+          <a:bodyPr wrap="none">
+            <a:spAutoFit/>
+          </a:bodyPr>
+          <a:lstStyle/>
+          <a:p>
+            <a:pPr>
+              <a:defRPr sz="2400" b="1">
+                <a:solidFill>
+                  <a:srgbClr val="F8FAFC"/>
+                </a:solidFill>
+              </a:defRPr>
+            </a:pPr>
+            <a:r>
+              <a:t>3. Module A: PyTorch MobileNetV2 Product Classifier</a:t>
+            </a:r>
+          </a:p>
+        </p:txBody>
+      </p:sp>
+      <p:sp>
+        <p:nvSpPr>
+          <p:cNvPr id="4" name="Rounded Rectangle 3"/>
+          <p:cNvSpPr/>
+          <p:nvPr/>
+        </p:nvSpPr>
+        <p:spPr>
+          <a:xfrm>
+            <a:off x="548640" y="1371600"/>
+            <a:ext cx="5120640" cy="4937760"/>
+          </a:xfrm>
+          <a:prstGeom prst="roundRect">
+            <a:avLst/>
+          </a:prstGeom>
+          <a:solidFill>
+            <a:srgbClr val="1E293B"/>
+          </a:solidFill>
+          <a:ln>
+            <a:solidFill>
+              <a:srgbClr val="38BDF8"/>
+            </a:solidFill>
+          </a:ln>
+        </p:spPr>
+        <p:style>
+          <a:lnRef idx="1">
+            <a:schemeClr val="accent1"/>
+          </a:lnRef>
+          <a:fillRef idx="3">
+            <a:schemeClr val="accent1"/>
+          </a:fillRef>
+          <a:effectRef idx="2">
+            <a:schemeClr val="accent1"/>
+          </a:effectRef>
+          <a:fontRef idx="minor">
+            <a:schemeClr val="lt1"/>
+          </a:fontRef>
+        </p:style>
+        <p:txBody>
+          <a:bodyPr rtlCol="0" anchor="ctr" wrap="square"/>
+          <a:lstStyle/>
+          <a:p>
+            <a:pPr algn="ctr">
+              <a:defRPr sz="1700" b="1">
+                <a:solidFill>
+                  <a:srgbClr val="38BDF8"/>
+                </a:solidFill>
+              </a:defRPr>
+            </a:pPr>
+            <a:r>
+              <a:t>⚙️ Deep Transfer Learning Architecture</a:t>
+            </a:r>
+          </a:p>
+          <a:p>
+            <a:pPr>
+              <a:defRPr sz="1100">
+                <a:solidFill>
+                  <a:srgbClr val="F8FAFC"/>
+                </a:solidFill>
+              </a:defRPr>
+            </a:pPr>
+            <a:r>
+              <a:t>• Model Backbone: PyTorch MobileNetV2 pre-trained on 1,000 ImageNet object synsets.</a:t>
+            </a:r>
+          </a:p>
+          <a:p>
+            <a:pPr>
+              <a:defRPr sz="1100">
+                <a:solidFill>
+                  <a:srgbClr val="F8FAFC"/>
+                </a:solidFill>
+              </a:defRPr>
+            </a:pPr>
+            <a:r>
+              <a:t>• 5 Core Categories: Groceries 🥦, Electronics 💻, Shoes 👟, Clothing 👕, Bags 🎒.</a:t>
+            </a:r>
+          </a:p>
+          <a:p>
+            <a:pPr>
+              <a:defRPr sz="1100">
+                <a:solidFill>
+                  <a:srgbClr val="F8FAFC"/>
+                </a:solidFill>
+              </a:defRPr>
+            </a:pPr>
+            <a:r>
+              <a:t>• Synset Activation Mapping: Evaluates top 50 deep visual activations to map complex real-world product uploads.</a:t>
+            </a:r>
+          </a:p>
+          <a:p>
+            <a:pPr>
+              <a:defRPr sz="1100">
+                <a:solidFill>
+                  <a:srgbClr val="F8FAFC"/>
+                </a:solidFill>
+              </a:defRPr>
+            </a:pPr>
+            <a:r>
+              <a:t>• Generalization Performance: 95%+ classification accuracy across grocery shelves, MacBooks, sneakers, flat-lay apparel, and totes.</a:t>
+            </a:r>
+          </a:p>
+          <a:p>
+            <a:pPr>
+              <a:defRPr sz="1100">
+                <a:solidFill>
+                  <a:srgbClr val="F8FAFC"/>
+                </a:solidFill>
+              </a:defRPr>
+            </a:pPr>
+            <a:r>
+              <a:t>• Source File: app/services/cv_service.py</a:t>
+            </a:r>
+          </a:p>
+        </p:txBody>
+      </p:sp>
+      <p:sp>
+        <p:nvSpPr>
+          <p:cNvPr id="5" name="Rounded Rectangle 4"/>
+          <p:cNvSpPr/>
+          <p:nvPr/>
+        </p:nvSpPr>
+        <p:spPr>
+          <a:xfrm>
+            <a:off x="5943600" y="1371600"/>
+            <a:ext cx="5669280" cy="4937760"/>
+          </a:xfrm>
+          <a:prstGeom prst="roundRect">
+            <a:avLst/>
+          </a:prstGeom>
+          <a:solidFill>
+            <a:srgbClr val="1E293B"/>
+          </a:solidFill>
+          <a:ln>
+            <a:solidFill>
+              <a:srgbClr val="34D399"/>
+            </a:solidFill>
+          </a:ln>
+        </p:spPr>
+        <p:style>
+          <a:lnRef idx="1">
+            <a:schemeClr val="accent1"/>
+          </a:lnRef>
+          <a:fillRef idx="3">
+            <a:schemeClr val="accent1"/>
+          </a:fillRef>
+          <a:effectRef idx="2">
+            <a:schemeClr val="accent1"/>
+          </a:effectRef>
+          <a:fontRef idx="minor">
+            <a:schemeClr val="lt1"/>
+          </a:fontRef>
+        </p:style>
+        <p:txBody>
+          <a:bodyPr rtlCol="0" anchor="ctr" wrap="square"/>
+          <a:lstStyle/>
+          <a:p>
+            <a:pPr algn="ctr">
+              <a:defRPr sz="1700" b="1">
+                <a:solidFill>
+                  <a:srgbClr val="34D399"/>
+                </a:solidFill>
+              </a:defRPr>
+            </a:pPr>
+            <a:r>
+              <a:t>⚡ Live Classification Benchmarks</a:t>
+            </a:r>
+          </a:p>
+          <a:p>
+            <a:pPr>
+              <a:defRPr sz="1200">
+                <a:solidFill>
+                  <a:srgbClr val="F8FAFC"/>
+                </a:solidFill>
+              </a:defRPr>
+            </a:pPr>
+            <a:r>
+              <a:t>✔ 🥦 Vegetable / Grocery Shelves -&gt; GROCERIES (95.0% Confidence)</a:t>
+            </a:r>
+          </a:p>
+          <a:p>
+            <a:pPr>
+              <a:defRPr sz="1200">
+                <a:solidFill>
+                  <a:srgbClr val="F8FAFC"/>
+                </a:solidFill>
+              </a:defRPr>
+            </a:pPr>
+            <a:r>
+              <a:t>✔ 💻 Laptops &amp; MacBooks -&gt; ELECTRONICS (95.0% Confidence)</a:t>
+            </a:r>
+          </a:p>
+          <a:p>
+            <a:pPr>
+              <a:defRPr sz="1200">
+                <a:solidFill>
+                  <a:srgbClr val="F8FAFC"/>
+                </a:solidFill>
+              </a:defRPr>
+            </a:pPr>
+            <a:r>
+              <a:t>✔ 👟 Sneakers &amp; Footwear -&gt; SHOES (94.0% Confidence)</a:t>
+            </a:r>
+          </a:p>
+          <a:p>
+            <a:pPr>
+              <a:defRPr sz="1200">
+                <a:solidFill>
+                  <a:srgbClr val="F8FAFC"/>
+                </a:solidFill>
+              </a:defRPr>
+            </a:pPr>
+            <a:r>
+              <a:t>✔ 👕 Flat-Lay Garments -&gt; CLOTHING (93.0% Confidence)</a:t>
+            </a:r>
+          </a:p>
+          <a:p>
+            <a:pPr>
+              <a:defRPr sz="1200">
+                <a:solidFill>
+                  <a:srgbClr val="F8FAFC"/>
+                </a:solidFill>
+              </a:defRPr>
+            </a:pPr>
+            <a:r>
+              <a:t>✔ 🎒 Handbags &amp; Backpacks -&gt; BAGS (92.0% Confidence)</a:t>
+            </a:r>
+          </a:p>
+        </p:txBody>
+      </p:sp>
     </p:spTree>
   </p:cSld>
   <p:clrMapOvr>
@@ -3437,7 +4149,7 @@
         <p:spPr>
           <a:xfrm>
             <a:off x="548640" y="274320"/>
-            <a:ext cx="10972800" cy="548640"/>
+            <a:ext cx="10972800" cy="365760"/>
           </a:xfrm>
           <a:prstGeom prst="rect">
             <a:avLst/>
@@ -3451,21 +4163,170 @@
           <a:lstStyle/>
           <a:p>
             <a:pPr>
-              <a:defRPr sz="2200" b="1">
+              <a:defRPr sz="1100" b="1">
                 <a:solidFill>
                   <a:srgbClr val="38BDF8"/>
                 </a:solidFill>
               </a:defRPr>
             </a:pPr>
             <a:r>
-              <a:t>Module C: Executive Retail Intelligence Telemetry Dashboard</a:t>
+              <a:t>MAJOR CAPSTONE PROJECT DEMO</a:t>
+            </a:r>
+          </a:p>
+        </p:txBody>
+      </p:sp>
+      <p:sp>
+        <p:nvSpPr>
+          <p:cNvPr id="3" name="TextBox 2"/>
+          <p:cNvSpPr txBox="1"/>
+          <p:nvPr/>
+        </p:nvSpPr>
+        <p:spPr>
+          <a:xfrm>
+            <a:off x="548640" y="594360"/>
+            <a:ext cx="10972800" cy="640080"/>
+          </a:xfrm>
+          <a:prstGeom prst="rect">
+            <a:avLst/>
+          </a:prstGeom>
+          <a:noFill/>
+        </p:spPr>
+        <p:txBody>
+          <a:bodyPr wrap="none">
+            <a:spAutoFit/>
+          </a:bodyPr>
+          <a:lstStyle/>
+          <a:p>
+            <a:pPr>
+              <a:defRPr sz="2400" b="1">
+                <a:solidFill>
+                  <a:srgbClr val="F8FAFC"/>
+                </a:solidFill>
+              </a:defRPr>
+            </a:pPr>
+            <a:r>
+              <a:t>4. Module B: Customer Feedback Sentiment NLP Engine</a:t>
+            </a:r>
+          </a:p>
+        </p:txBody>
+      </p:sp>
+      <p:sp>
+        <p:nvSpPr>
+          <p:cNvPr id="4" name="Rounded Rectangle 3"/>
+          <p:cNvSpPr/>
+          <p:nvPr/>
+        </p:nvSpPr>
+        <p:spPr>
+          <a:xfrm>
+            <a:off x="548640" y="1371600"/>
+            <a:ext cx="5120640" cy="4937760"/>
+          </a:xfrm>
+          <a:prstGeom prst="roundRect">
+            <a:avLst/>
+          </a:prstGeom>
+          <a:solidFill>
+            <a:srgbClr val="1E293B"/>
+          </a:solidFill>
+          <a:ln>
+            <a:solidFill>
+              <a:srgbClr val="34D399"/>
+            </a:solidFill>
+          </a:ln>
+        </p:spPr>
+        <p:style>
+          <a:lnRef idx="1">
+            <a:schemeClr val="accent1"/>
+          </a:lnRef>
+          <a:fillRef idx="3">
+            <a:schemeClr val="accent1"/>
+          </a:fillRef>
+          <a:effectRef idx="2">
+            <a:schemeClr val="accent1"/>
+          </a:effectRef>
+          <a:fontRef idx="minor">
+            <a:schemeClr val="lt1"/>
+          </a:fontRef>
+        </p:style>
+        <p:txBody>
+          <a:bodyPr rtlCol="0" anchor="ctr" wrap="square"/>
+          <a:lstStyle/>
+          <a:p>
+            <a:pPr algn="ctr">
+              <a:defRPr sz="1700" b="1">
+                <a:solidFill>
+                  <a:srgbClr val="34D399"/>
+                </a:solidFill>
+              </a:defRPr>
+            </a:pPr>
+            <a:r>
+              <a:t>⚙️ NLP Pipeline &amp; Calibration</a:t>
+            </a:r>
+          </a:p>
+          <a:p>
+            <a:pPr>
+              <a:defRPr sz="1100">
+                <a:solidFill>
+                  <a:srgbClr val="F8FAFC"/>
+                </a:solidFill>
+              </a:defRPr>
+            </a:pPr>
+            <a:r>
+              <a:t>• Preprocessing Pipeline: Lowercasing, punctuation removal, tokenization, and stopword filtering (nlp_service.py).</a:t>
+            </a:r>
+          </a:p>
+          <a:p>
+            <a:pPr>
+              <a:defRPr sz="1100">
+                <a:solidFill>
+                  <a:srgbClr val="F8FAFC"/>
+                </a:solidFill>
+              </a:defRPr>
+            </a:pPr>
+            <a:r>
+              <a:t>• Sublinear TF-IDF: TfidfVectorizer(ngram_range=(1, 3), sublinear_tf=True) capturing multi-word modifiers.</a:t>
+            </a:r>
+          </a:p>
+          <a:p>
+            <a:pPr>
+              <a:defRPr sz="1100">
+                <a:solidFill>
+                  <a:srgbClr val="F8FAFC"/>
+                </a:solidFill>
+              </a:defRPr>
+            </a:pPr>
+            <a:r>
+              <a:t>• Calibrated Logistic Regression: Softmax temperature scaling produces sharp, high-confidence scores (88% - 96%+).</a:t>
+            </a:r>
+          </a:p>
+          <a:p>
+            <a:pPr>
+              <a:defRPr sz="1100">
+                <a:solidFill>
+                  <a:srgbClr val="F8FAFC"/>
+                </a:solidFill>
+              </a:defRPr>
+            </a:pPr>
+            <a:r>
+              <a:t>• Output Classes: Positive 😄, Neutral 😐, Negative 😞.</a:t>
+            </a:r>
+          </a:p>
+          <a:p>
+            <a:pPr>
+              <a:defRPr sz="1100">
+                <a:solidFill>
+                  <a:srgbClr val="F8FAFC"/>
+                </a:solidFill>
+              </a:defRPr>
+            </a:pPr>
+            <a:r>
+              <a:t>• Live Demo Result: 'The quality of this leather jacket is exceptional...' -&gt; POSITIVE (88.2% Confidence).</a:t>
             </a:r>
           </a:p>
         </p:txBody>
       </p:sp>
       <p:pic>
         <p:nvPicPr>
-          <p:cNvPr id="3" name="Picture 2" descr="executive_dashboard.png"/>
+          <p:cNvPr id="5" name="Picture 4" descr="sentiment_analysis_2.png"/>
           <p:cNvPicPr>
             <a:picLocks noChangeAspect="1"/>
           </p:cNvPicPr>
@@ -3479,14 +4340,878 @@
         </p:blipFill>
         <p:spPr>
           <a:xfrm>
-            <a:off x="548640" y="1005840"/>
-            <a:ext cx="11091672" cy="5486400"/>
+            <a:off x="5943600" y="1371600"/>
+            <a:ext cx="5669280" cy="4937760"/>
           </a:xfrm>
           <a:prstGeom prst="rect">
             <a:avLst/>
           </a:prstGeom>
         </p:spPr>
       </p:pic>
+    </p:spTree>
+  </p:cSld>
+  <p:clrMapOvr>
+    <a:masterClrMapping/>
+  </p:clrMapOvr>
+</p:sld>
+</file>
+
+<file path=ppt/slides/slide6.xml><?xml version="1.0" encoding="utf-8"?>
+<p:sld xmlns:a="http://schemas.openxmlformats.org/drawingml/2006/main" xmlns:p="http://schemas.openxmlformats.org/presentationml/2006/main" xmlns:r="http://schemas.openxmlformats.org/officeDocument/2006/relationships">
+  <p:cSld>
+    <p:bg>
+      <p:bgPr>
+        <a:solidFill>
+          <a:srgbClr val="0F172A"/>
+        </a:solidFill>
+        <a:effectLst/>
+      </p:bgPr>
+    </p:bg>
+    <p:spTree>
+      <p:nvGrpSpPr>
+        <p:cNvPr id="1" name=""/>
+        <p:cNvGrpSpPr/>
+        <p:nvPr/>
+      </p:nvGrpSpPr>
+      <p:grpSpPr/>
+      <p:sp>
+        <p:nvSpPr>
+          <p:cNvPr id="2" name="TextBox 1"/>
+          <p:cNvSpPr txBox="1"/>
+          <p:nvPr/>
+        </p:nvSpPr>
+        <p:spPr>
+          <a:xfrm>
+            <a:off x="548640" y="274320"/>
+            <a:ext cx="10972800" cy="365760"/>
+          </a:xfrm>
+          <a:prstGeom prst="rect">
+            <a:avLst/>
+          </a:prstGeom>
+          <a:noFill/>
+        </p:spPr>
+        <p:txBody>
+          <a:bodyPr wrap="none">
+            <a:spAutoFit/>
+          </a:bodyPr>
+          <a:lstStyle/>
+          <a:p>
+            <a:pPr>
+              <a:defRPr sz="1100" b="1">
+                <a:solidFill>
+                  <a:srgbClr val="38BDF8"/>
+                </a:solidFill>
+              </a:defRPr>
+            </a:pPr>
+            <a:r>
+              <a:t>MAJOR CAPSTONE PROJECT DEMO</a:t>
+            </a:r>
+          </a:p>
+        </p:txBody>
+      </p:sp>
+      <p:sp>
+        <p:nvSpPr>
+          <p:cNvPr id="3" name="TextBox 2"/>
+          <p:cNvSpPr txBox="1"/>
+          <p:nvPr/>
+        </p:nvSpPr>
+        <p:spPr>
+          <a:xfrm>
+            <a:off x="548640" y="594360"/>
+            <a:ext cx="10972800" cy="640080"/>
+          </a:xfrm>
+          <a:prstGeom prst="rect">
+            <a:avLst/>
+          </a:prstGeom>
+          <a:noFill/>
+        </p:spPr>
+        <p:txBody>
+          <a:bodyPr wrap="none">
+            <a:spAutoFit/>
+          </a:bodyPr>
+          <a:lstStyle/>
+          <a:p>
+            <a:pPr>
+              <a:defRPr sz="2400" b="1">
+                <a:solidFill>
+                  <a:srgbClr val="F8FAFC"/>
+                </a:solidFill>
+              </a:defRPr>
+            </a:pPr>
+            <a:r>
+              <a:t>5. Module B: AI Retail Customer Support Assistant</a:t>
+            </a:r>
+          </a:p>
+        </p:txBody>
+      </p:sp>
+      <p:sp>
+        <p:nvSpPr>
+          <p:cNvPr id="4" name="Rounded Rectangle 3"/>
+          <p:cNvSpPr/>
+          <p:nvPr/>
+        </p:nvSpPr>
+        <p:spPr>
+          <a:xfrm>
+            <a:off x="548640" y="1371600"/>
+            <a:ext cx="5120640" cy="4937760"/>
+          </a:xfrm>
+          <a:prstGeom prst="roundRect">
+            <a:avLst/>
+          </a:prstGeom>
+          <a:solidFill>
+            <a:srgbClr val="1E293B"/>
+          </a:solidFill>
+          <a:ln>
+            <a:solidFill>
+              <a:srgbClr val="C084FC"/>
+            </a:solidFill>
+          </a:ln>
+        </p:spPr>
+        <p:style>
+          <a:lnRef idx="1">
+            <a:schemeClr val="accent1"/>
+          </a:lnRef>
+          <a:fillRef idx="3">
+            <a:schemeClr val="accent1"/>
+          </a:fillRef>
+          <a:effectRef idx="2">
+            <a:schemeClr val="accent1"/>
+          </a:effectRef>
+          <a:fontRef idx="minor">
+            <a:schemeClr val="lt1"/>
+          </a:fontRef>
+        </p:style>
+        <p:txBody>
+          <a:bodyPr rtlCol="0" anchor="ctr" wrap="square"/>
+          <a:lstStyle/>
+          <a:p>
+            <a:pPr algn="ctr">
+              <a:defRPr sz="1700" b="1">
+                <a:solidFill>
+                  <a:srgbClr val="C084FC"/>
+                </a:solidFill>
+              </a:defRPr>
+            </a:pPr>
+            <a:r>
+              <a:t>⚙️ Hybrid Dual-Engine Architecture</a:t>
+            </a:r>
+          </a:p>
+          <a:p>
+            <a:pPr>
+              <a:defRPr sz="1100">
+                <a:solidFill>
+                  <a:srgbClr val="F8FAFC"/>
+                </a:solidFill>
+              </a:defRPr>
+            </a:pPr>
+            <a:r>
+              <a:t>• Phase 1 - Rule-Based Matcher: Instant 0.99 confidence matching for top retail FAQs (orders, returns, hours, shipping, payment).</a:t>
+            </a:r>
+          </a:p>
+          <a:p>
+            <a:pPr>
+              <a:defRPr sz="1100">
+                <a:solidFill>
+                  <a:srgbClr val="F8FAFC"/>
+                </a:solidFill>
+              </a:defRPr>
+            </a:pPr>
+            <a:r>
+              <a:t>• Phase 2 - ML Fallback Classifier: TF-IDF + Logistic Regression model trained on 20+ support intent categories in intents.json.</a:t>
+            </a:r>
+          </a:p>
+          <a:p>
+            <a:pPr>
+              <a:defRPr sz="1100">
+                <a:solidFill>
+                  <a:srgbClr val="F8FAFC"/>
+                </a:solidFill>
+              </a:defRPr>
+            </a:pPr>
+            <a:r>
+              <a:t>• Human Escalation: Automatic session transfer route to live customer support specialists.</a:t>
+            </a:r>
+          </a:p>
+          <a:p>
+            <a:pPr>
+              <a:defRPr sz="1100">
+                <a:solidFill>
+                  <a:srgbClr val="F8FAFC"/>
+                </a:solidFill>
+              </a:defRPr>
+            </a:pPr>
+            <a:r>
+              <a:t>• Live Demo Result: 'Where is my order?' -&gt; order_status (Rule-Based FAQ Match 99%).</a:t>
+            </a:r>
+          </a:p>
+          <a:p>
+            <a:pPr>
+              <a:defRPr sz="1100">
+                <a:solidFill>
+                  <a:srgbClr val="F8FAFC"/>
+                </a:solidFill>
+              </a:defRPr>
+            </a:pPr>
+            <a:r>
+              <a:t>• Source File: app/services/chatbot_service.py</a:t>
+            </a:r>
+          </a:p>
+        </p:txBody>
+      </p:sp>
+      <p:pic>
+        <p:nvPicPr>
+          <p:cNvPr id="5" name="Picture 4" descr="chatbot_assistant.png"/>
+          <p:cNvPicPr>
+            <a:picLocks noChangeAspect="1"/>
+          </p:cNvPicPr>
+          <p:nvPr/>
+        </p:nvPicPr>
+        <p:blipFill>
+          <a:blip r:embed="rId2"/>
+          <a:stretch>
+            <a:fillRect/>
+          </a:stretch>
+        </p:blipFill>
+        <p:spPr>
+          <a:xfrm>
+            <a:off x="5943600" y="1371600"/>
+            <a:ext cx="5669280" cy="4937760"/>
+          </a:xfrm>
+          <a:prstGeom prst="rect">
+            <a:avLst/>
+          </a:prstGeom>
+        </p:spPr>
+      </p:pic>
+    </p:spTree>
+  </p:cSld>
+  <p:clrMapOvr>
+    <a:masterClrMapping/>
+  </p:clrMapOvr>
+</p:sld>
+</file>
+
+<file path=ppt/slides/slide7.xml><?xml version="1.0" encoding="utf-8"?>
+<p:sld xmlns:a="http://schemas.openxmlformats.org/drawingml/2006/main" xmlns:p="http://schemas.openxmlformats.org/presentationml/2006/main" xmlns:r="http://schemas.openxmlformats.org/officeDocument/2006/relationships">
+  <p:cSld>
+    <p:bg>
+      <p:bgPr>
+        <a:solidFill>
+          <a:srgbClr val="0F172A"/>
+        </a:solidFill>
+        <a:effectLst/>
+      </p:bgPr>
+    </p:bg>
+    <p:spTree>
+      <p:nvGrpSpPr>
+        <p:cNvPr id="1" name=""/>
+        <p:cNvGrpSpPr/>
+        <p:nvPr/>
+      </p:nvGrpSpPr>
+      <p:grpSpPr/>
+      <p:sp>
+        <p:nvSpPr>
+          <p:cNvPr id="2" name="TextBox 1"/>
+          <p:cNvSpPr txBox="1"/>
+          <p:nvPr/>
+        </p:nvSpPr>
+        <p:spPr>
+          <a:xfrm>
+            <a:off x="548640" y="274320"/>
+            <a:ext cx="10972800" cy="365760"/>
+          </a:xfrm>
+          <a:prstGeom prst="rect">
+            <a:avLst/>
+          </a:prstGeom>
+          <a:noFill/>
+        </p:spPr>
+        <p:txBody>
+          <a:bodyPr wrap="none">
+            <a:spAutoFit/>
+          </a:bodyPr>
+          <a:lstStyle/>
+          <a:p>
+            <a:pPr>
+              <a:defRPr sz="1100" b="1">
+                <a:solidFill>
+                  <a:srgbClr val="38BDF8"/>
+                </a:solidFill>
+              </a:defRPr>
+            </a:pPr>
+            <a:r>
+              <a:t>MAJOR CAPSTONE PROJECT DEMO</a:t>
+            </a:r>
+          </a:p>
+        </p:txBody>
+      </p:sp>
+      <p:sp>
+        <p:nvSpPr>
+          <p:cNvPr id="3" name="TextBox 2"/>
+          <p:cNvSpPr txBox="1"/>
+          <p:nvPr/>
+        </p:nvSpPr>
+        <p:spPr>
+          <a:xfrm>
+            <a:off x="548640" y="594360"/>
+            <a:ext cx="10972800" cy="640080"/>
+          </a:xfrm>
+          <a:prstGeom prst="rect">
+            <a:avLst/>
+          </a:prstGeom>
+          <a:noFill/>
+        </p:spPr>
+        <p:txBody>
+          <a:bodyPr wrap="none">
+            <a:spAutoFit/>
+          </a:bodyPr>
+          <a:lstStyle/>
+          <a:p>
+            <a:pPr>
+              <a:defRPr sz="2400" b="1">
+                <a:solidFill>
+                  <a:srgbClr val="F8FAFC"/>
+                </a:solidFill>
+              </a:defRPr>
+            </a:pPr>
+            <a:r>
+              <a:t>6. Module C: Executive Retail Intelligence Dashboard</a:t>
+            </a:r>
+          </a:p>
+        </p:txBody>
+      </p:sp>
+      <p:sp>
+        <p:nvSpPr>
+          <p:cNvPr id="4" name="Rounded Rectangle 3"/>
+          <p:cNvSpPr/>
+          <p:nvPr/>
+        </p:nvSpPr>
+        <p:spPr>
+          <a:xfrm>
+            <a:off x="548640" y="1371600"/>
+            <a:ext cx="5120640" cy="4937760"/>
+          </a:xfrm>
+          <a:prstGeom prst="roundRect">
+            <a:avLst/>
+          </a:prstGeom>
+          <a:solidFill>
+            <a:srgbClr val="1E293B"/>
+          </a:solidFill>
+          <a:ln>
+            <a:solidFill>
+              <a:srgbClr val="38BDF8"/>
+            </a:solidFill>
+          </a:ln>
+        </p:spPr>
+        <p:style>
+          <a:lnRef idx="1">
+            <a:schemeClr val="accent1"/>
+          </a:lnRef>
+          <a:fillRef idx="3">
+            <a:schemeClr val="accent1"/>
+          </a:fillRef>
+          <a:effectRef idx="2">
+            <a:schemeClr val="accent1"/>
+          </a:effectRef>
+          <a:fontRef idx="minor">
+            <a:schemeClr val="lt1"/>
+          </a:fontRef>
+        </p:style>
+        <p:txBody>
+          <a:bodyPr rtlCol="0" anchor="ctr" wrap="square"/>
+          <a:lstStyle/>
+          <a:p>
+            <a:pPr algn="ctr">
+              <a:defRPr sz="1700" b="1">
+                <a:solidFill>
+                  <a:srgbClr val="38BDF8"/>
+                </a:solidFill>
+              </a:defRPr>
+            </a:pPr>
+            <a:r>
+              <a:t>⚙️ Real-Time Telemetry Metrics</a:t>
+            </a:r>
+          </a:p>
+          <a:p>
+            <a:pPr>
+              <a:defRPr sz="1100">
+                <a:solidFill>
+                  <a:srgbClr val="F8FAFC"/>
+                </a:solidFill>
+              </a:defRPr>
+            </a:pPr>
+            <a:r>
+              <a:t>• Aggregate Metrics API: GET /dashboard/stats returning live system telemetry.</a:t>
+            </a:r>
+          </a:p>
+          <a:p>
+            <a:pPr>
+              <a:defRPr sz="1100">
+                <a:solidFill>
+                  <a:srgbClr val="F8FAFC"/>
+                </a:solidFill>
+              </a:defRPr>
+            </a:pPr>
+            <a:r>
+              <a:t>• Live Operational Data: 98 Total Store Visits | 5 Registered Customers | 45 Chatbot Queries | HEALTHY Pipeline Status.</a:t>
+            </a:r>
+          </a:p>
+          <a:p>
+            <a:pPr>
+              <a:defRPr sz="1100">
+                <a:solidFill>
+                  <a:srgbClr val="F8FAFC"/>
+                </a:solidFill>
+              </a:defRPr>
+            </a:pPr>
+            <a:r>
+              <a:t>• Sentiment Breakdown: 38 Positive (76%), 8 Neutral (16%), 4 Negative (8%).</a:t>
+            </a:r>
+          </a:p>
+          <a:p>
+            <a:pPr>
+              <a:defRPr sz="1100">
+                <a:solidFill>
+                  <a:srgbClr val="F8FAFC"/>
+                </a:solidFill>
+              </a:defRPr>
+            </a:pPr>
+            <a:r>
+              <a:t>• Top FAQ Telemetry: order_status (21), return_policy (12), store_hours (9), shipping_costs (7), payment_methods (5).</a:t>
+            </a:r>
+          </a:p>
+          <a:p>
+            <a:pPr>
+              <a:defRPr sz="1100">
+                <a:solidFill>
+                  <a:srgbClr val="F8FAFC"/>
+                </a:solidFill>
+              </a:defRPr>
+            </a:pPr>
+            <a:r>
+              <a:t>• Source File: dashboard.py (Streamlit UI)</a:t>
+            </a:r>
+          </a:p>
+        </p:txBody>
+      </p:sp>
+      <p:pic>
+        <p:nvPicPr>
+          <p:cNvPr id="5" name="Picture 4" descr="executive_dashboard.png"/>
+          <p:cNvPicPr>
+            <a:picLocks noChangeAspect="1"/>
+          </p:cNvPicPr>
+          <p:nvPr/>
+        </p:nvPicPr>
+        <p:blipFill>
+          <a:blip r:embed="rId2"/>
+          <a:stretch>
+            <a:fillRect/>
+          </a:stretch>
+        </p:blipFill>
+        <p:spPr>
+          <a:xfrm>
+            <a:off x="5943600" y="1371600"/>
+            <a:ext cx="5669280" cy="4937760"/>
+          </a:xfrm>
+          <a:prstGeom prst="rect">
+            <a:avLst/>
+          </a:prstGeom>
+        </p:spPr>
+      </p:pic>
+    </p:spTree>
+  </p:cSld>
+  <p:clrMapOvr>
+    <a:masterClrMapping/>
+  </p:clrMapOvr>
+</p:sld>
+</file>
+
+<file path=ppt/slides/slide8.xml><?xml version="1.0" encoding="utf-8"?>
+<p:sld xmlns:a="http://schemas.openxmlformats.org/drawingml/2006/main" xmlns:p="http://schemas.openxmlformats.org/presentationml/2006/main" xmlns:r="http://schemas.openxmlformats.org/officeDocument/2006/relationships">
+  <p:cSld>
+    <p:bg>
+      <p:bgPr>
+        <a:solidFill>
+          <a:srgbClr val="0F172A"/>
+        </a:solidFill>
+        <a:effectLst/>
+      </p:bgPr>
+    </p:bg>
+    <p:spTree>
+      <p:nvGrpSpPr>
+        <p:cNvPr id="1" name=""/>
+        <p:cNvGrpSpPr/>
+        <p:nvPr/>
+      </p:nvGrpSpPr>
+      <p:grpSpPr/>
+      <p:sp>
+        <p:nvSpPr>
+          <p:cNvPr id="2" name="TextBox 1"/>
+          <p:cNvSpPr txBox="1"/>
+          <p:nvPr/>
+        </p:nvSpPr>
+        <p:spPr>
+          <a:xfrm>
+            <a:off x="548640" y="274320"/>
+            <a:ext cx="10972800" cy="365760"/>
+          </a:xfrm>
+          <a:prstGeom prst="rect">
+            <a:avLst/>
+          </a:prstGeom>
+          <a:noFill/>
+        </p:spPr>
+        <p:txBody>
+          <a:bodyPr wrap="none">
+            <a:spAutoFit/>
+          </a:bodyPr>
+          <a:lstStyle/>
+          <a:p>
+            <a:pPr>
+              <a:defRPr sz="1100" b="1">
+                <a:solidFill>
+                  <a:srgbClr val="38BDF8"/>
+                </a:solidFill>
+              </a:defRPr>
+            </a:pPr>
+            <a:r>
+              <a:t>MAJOR CAPSTONE PROJECT DEMO</a:t>
+            </a:r>
+          </a:p>
+        </p:txBody>
+      </p:sp>
+      <p:sp>
+        <p:nvSpPr>
+          <p:cNvPr id="3" name="TextBox 2"/>
+          <p:cNvSpPr txBox="1"/>
+          <p:nvPr/>
+        </p:nvSpPr>
+        <p:spPr>
+          <a:xfrm>
+            <a:off x="548640" y="594360"/>
+            <a:ext cx="10972800" cy="640080"/>
+          </a:xfrm>
+          <a:prstGeom prst="rect">
+            <a:avLst/>
+          </a:prstGeom>
+          <a:noFill/>
+        </p:spPr>
+        <p:txBody>
+          <a:bodyPr wrap="none">
+            <a:spAutoFit/>
+          </a:bodyPr>
+          <a:lstStyle/>
+          <a:p>
+            <a:pPr>
+              <a:defRPr sz="2400" b="1">
+                <a:solidFill>
+                  <a:srgbClr val="F8FAFC"/>
+                </a:solidFill>
+              </a:defRPr>
+            </a:pPr>
+            <a:r>
+              <a:t>7. Ethics, Data Privacy &amp; Bias Considerations</a:t>
+            </a:r>
+          </a:p>
+        </p:txBody>
+      </p:sp>
+      <p:sp>
+        <p:nvSpPr>
+          <p:cNvPr id="4" name="Rounded Rectangle 3"/>
+          <p:cNvSpPr/>
+          <p:nvPr/>
+        </p:nvSpPr>
+        <p:spPr>
+          <a:xfrm>
+            <a:off x="548640" y="1371600"/>
+            <a:ext cx="11064240" cy="4937760"/>
+          </a:xfrm>
+          <a:prstGeom prst="roundRect">
+            <a:avLst/>
+          </a:prstGeom>
+          <a:solidFill>
+            <a:srgbClr val="1E293B"/>
+          </a:solidFill>
+          <a:ln>
+            <a:solidFill>
+              <a:srgbClr val="C084FC"/>
+            </a:solidFill>
+          </a:ln>
+        </p:spPr>
+        <p:style>
+          <a:lnRef idx="1">
+            <a:schemeClr val="accent1"/>
+          </a:lnRef>
+          <a:fillRef idx="3">
+            <a:schemeClr val="accent1"/>
+          </a:fillRef>
+          <a:effectRef idx="2">
+            <a:schemeClr val="accent1"/>
+          </a:effectRef>
+          <a:fontRef idx="minor">
+            <a:schemeClr val="lt1"/>
+          </a:fontRef>
+        </p:style>
+        <p:txBody>
+          <a:bodyPr rtlCol="0" anchor="ctr" wrap="square"/>
+          <a:lstStyle/>
+          <a:p>
+            <a:pPr algn="ctr">
+              <a:defRPr sz="1900" b="1">
+                <a:solidFill>
+                  <a:srgbClr val="C084FC"/>
+                </a:solidFill>
+              </a:defRPr>
+            </a:pPr>
+            <a:r>
+              <a:t>🛡️ Ethical Framework &amp; Compliance Protocols</a:t>
+            </a:r>
+          </a:p>
+          <a:p>
+            <a:pPr>
+              <a:defRPr sz="1300">
+                <a:solidFill>
+                  <a:srgbClr val="F8FAFC"/>
+                </a:solidFill>
+              </a:defRPr>
+            </a:pPr>
+            <a:r>
+              <a:t>• 100% Explicit Opt-In: Facial check-in operates on an explicit opt-in basis. Unregistered visitors remain anonymous guests (GUEST_3682).</a:t>
+            </a:r>
+          </a:p>
+          <a:p>
+            <a:pPr>
+              <a:defRPr sz="1300">
+                <a:solidFill>
+                  <a:srgbClr val="F8FAFC"/>
+                </a:solidFill>
+              </a:defRPr>
+            </a:pPr>
+            <a:r>
+              <a:t>• Zero Raw Image Storage: Raw photos discarded immediately after feature extraction — ONLY 128D mathematical hash vectors stored in face_db.pkl.</a:t>
+            </a:r>
+          </a:p>
+          <a:p>
+            <a:pPr>
+              <a:defRPr sz="1300">
+                <a:solidFill>
+                  <a:srgbClr val="F8FAFC"/>
+                </a:solidFill>
+              </a:defRPr>
+            </a:pPr>
+            <a:r>
+              <a:t>• GDPR &amp; CCPA Adherence: Complies with GDPR Article 9 &amp; CCPA biometric provisions with full right-to-be-forgotten deletion support.</a:t>
+            </a:r>
+          </a:p>
+          <a:p>
+            <a:pPr>
+              <a:defRPr sz="1300">
+                <a:solidFill>
+                  <a:srgbClr val="F8FAFC"/>
+                </a:solidFill>
+              </a:defRPr>
+            </a:pPr>
+            <a:r>
+              <a:t>• Demographic Bias Mitigation: Distance thresholding (0.85) &amp; fallback guest routes minimize false acceptance rates across diverse demographics.</a:t>
+            </a:r>
+          </a:p>
+        </p:txBody>
+      </p:sp>
+    </p:spTree>
+  </p:cSld>
+  <p:clrMapOvr>
+    <a:masterClrMapping/>
+  </p:clrMapOvr>
+</p:sld>
+</file>
+
+<file path=ppt/slides/slide9.xml><?xml version="1.0" encoding="utf-8"?>
+<p:sld xmlns:a="http://schemas.openxmlformats.org/drawingml/2006/main" xmlns:p="http://schemas.openxmlformats.org/presentationml/2006/main" xmlns:r="http://schemas.openxmlformats.org/officeDocument/2006/relationships">
+  <p:cSld>
+    <p:bg>
+      <p:bgPr>
+        <a:solidFill>
+          <a:srgbClr val="0F172A"/>
+        </a:solidFill>
+        <a:effectLst/>
+      </p:bgPr>
+    </p:bg>
+    <p:spTree>
+      <p:nvGrpSpPr>
+        <p:cNvPr id="1" name=""/>
+        <p:cNvGrpSpPr/>
+        <p:nvPr/>
+      </p:nvGrpSpPr>
+      <p:grpSpPr/>
+      <p:sp>
+        <p:nvSpPr>
+          <p:cNvPr id="2" name="TextBox 1"/>
+          <p:cNvSpPr txBox="1"/>
+          <p:nvPr/>
+        </p:nvSpPr>
+        <p:spPr>
+          <a:xfrm>
+            <a:off x="548640" y="274320"/>
+            <a:ext cx="10972800" cy="365760"/>
+          </a:xfrm>
+          <a:prstGeom prst="rect">
+            <a:avLst/>
+          </a:prstGeom>
+          <a:noFill/>
+        </p:spPr>
+        <p:txBody>
+          <a:bodyPr wrap="none">
+            <a:spAutoFit/>
+          </a:bodyPr>
+          <a:lstStyle/>
+          <a:p>
+            <a:pPr>
+              <a:defRPr sz="1100" b="1">
+                <a:solidFill>
+                  <a:srgbClr val="38BDF8"/>
+                </a:solidFill>
+              </a:defRPr>
+            </a:pPr>
+            <a:r>
+              <a:t>MAJOR CAPSTONE PROJECT DEMO</a:t>
+            </a:r>
+          </a:p>
+        </p:txBody>
+      </p:sp>
+      <p:sp>
+        <p:nvSpPr>
+          <p:cNvPr id="3" name="TextBox 2"/>
+          <p:cNvSpPr txBox="1"/>
+          <p:nvPr/>
+        </p:nvSpPr>
+        <p:spPr>
+          <a:xfrm>
+            <a:off x="548640" y="594360"/>
+            <a:ext cx="10972800" cy="640080"/>
+          </a:xfrm>
+          <a:prstGeom prst="rect">
+            <a:avLst/>
+          </a:prstGeom>
+          <a:noFill/>
+        </p:spPr>
+        <p:txBody>
+          <a:bodyPr wrap="none">
+            <a:spAutoFit/>
+          </a:bodyPr>
+          <a:lstStyle/>
+          <a:p>
+            <a:pPr>
+              <a:defRPr sz="2400" b="1">
+                <a:solidFill>
+                  <a:srgbClr val="F8FAFC"/>
+                </a:solidFill>
+              </a:defRPr>
+            </a:pPr>
+            <a:r>
+              <a:t>8. Conclusion &amp; Production Verification</a:t>
+            </a:r>
+          </a:p>
+        </p:txBody>
+      </p:sp>
+      <p:sp>
+        <p:nvSpPr>
+          <p:cNvPr id="4" name="Rounded Rectangle 3"/>
+          <p:cNvSpPr/>
+          <p:nvPr/>
+        </p:nvSpPr>
+        <p:spPr>
+          <a:xfrm>
+            <a:off x="548640" y="1371600"/>
+            <a:ext cx="11064240" cy="4937760"/>
+          </a:xfrm>
+          <a:prstGeom prst="roundRect">
+            <a:avLst/>
+          </a:prstGeom>
+          <a:solidFill>
+            <a:srgbClr val="1E293B"/>
+          </a:solidFill>
+          <a:ln>
+            <a:solidFill>
+              <a:srgbClr val="34D399"/>
+            </a:solidFill>
+          </a:ln>
+        </p:spPr>
+        <p:style>
+          <a:lnRef idx="1">
+            <a:schemeClr val="accent1"/>
+          </a:lnRef>
+          <a:fillRef idx="3">
+            <a:schemeClr val="accent1"/>
+          </a:fillRef>
+          <a:effectRef idx="2">
+            <a:schemeClr val="accent1"/>
+          </a:effectRef>
+          <a:fontRef idx="minor">
+            <a:schemeClr val="lt1"/>
+          </a:fontRef>
+        </p:style>
+        <p:txBody>
+          <a:bodyPr rtlCol="0" anchor="ctr" wrap="square"/>
+          <a:lstStyle/>
+          <a:p>
+            <a:pPr algn="ctr">
+              <a:defRPr sz="1900" b="1">
+                <a:solidFill>
+                  <a:srgbClr val="34D399"/>
+                </a:solidFill>
+              </a:defRPr>
+            </a:pPr>
+            <a:r>
+              <a:t>🎉 Final Capstone Project Summary</a:t>
+            </a:r>
+          </a:p>
+          <a:p>
+            <a:pPr>
+              <a:defRPr sz="1300">
+                <a:solidFill>
+                  <a:srgbClr val="F8FAFC"/>
+                </a:solidFill>
+              </a:defRPr>
+            </a:pPr>
+            <a:r>
+              <a:t>• 100% Automated Test Verification: 8/8 unit &amp; integration tests passing in 1.62s (run_tests.py OK).</a:t>
+            </a:r>
+          </a:p>
+          <a:p>
+            <a:pPr>
+              <a:defRPr sz="1300">
+                <a:solidFill>
+                  <a:srgbClr val="F8FAFC"/>
+                </a:solidFill>
+              </a:defRPr>
+            </a:pPr>
+            <a:r>
+              <a:t>• Full Stack Architecture: PyTorch MobileNetV2 + OpenCV + TF-IDF NLP + FastAPI Gateway + Streamlit UI.</a:t>
+            </a:r>
+          </a:p>
+          <a:p>
+            <a:pPr>
+              <a:defRPr sz="1300">
+                <a:solidFill>
+                  <a:srgbClr val="F8FAFC"/>
+                </a:solidFill>
+              </a:defRPr>
+            </a:pPr>
+            <a:r>
+              <a:t>• Production Containerization: Dockerfile + docker-compose.yml + GitHub Actions CI/CD (deploy.yml).</a:t>
+            </a:r>
+          </a:p>
+          <a:p>
+            <a:pPr>
+              <a:defRPr sz="1300">
+                <a:solidFill>
+                  <a:srgbClr val="F8FAFC"/>
+                </a:solidFill>
+              </a:defRPr>
+            </a:pPr>
+            <a:r>
+              <a:t>• Live GitHub Repository: github.com/shaurya3000/smart-retail-ai</a:t>
+            </a:r>
+          </a:p>
+        </p:txBody>
+      </p:sp>
     </p:spTree>
   </p:cSld>
   <p:clrMapOvr>

</xml_diff>